<commit_message>
Restyle trade-off matrix (contiguous grid, Efficient-first right column) and clarify workflow into labeled Step 1/2/3 phase bands
</commit_message>
<xml_diff>
--- a/output/guardrail_matrix.pptx
+++ b/output/guardrail_matrix.pptx
@@ -925,17 +925,15 @@
             <a:off x="2148840" y="1234440"/>
             <a:ext cx="4480560" cy="2103120"/>
           </a:xfrm>
-          <a:prstGeom prst="roundRect">
-            <a:avLst>
-              <a:gd name="adj" fmla="val 3478"/>
-            </a:avLst>
-          </a:prstGeom>
-          <a:solidFill>
-            <a:srgbClr val="EFEFEF"/>
-          </a:solidFill>
-          <a:ln w="25400">
+          <a:prstGeom prst="rect">
+            <a:avLst/>
+          </a:prstGeom>
+          <a:solidFill>
+            <a:srgbClr val="EDEDED"/>
+          </a:solidFill>
+          <a:ln w="12700">
             <a:solidFill>
-              <a:srgbClr val="000000"/>
+              <a:srgbClr val="9A9A9A"/>
             </a:solidFill>
             <a:prstDash val="solid"/>
           </a:ln>
@@ -964,14 +962,14 @@
           <a:p>
             <a:pPr algn="ctr" indent="0" marL="0">
               <a:lnSpc>
-                <a:spcPct val="108000"/>
+                <a:spcPct val="110000"/>
               </a:lnSpc>
               <a:buNone/>
             </a:pPr>
             <a:r>
               <a:rPr lang="en-US" sz="1700" b="1" dirty="0">
                 <a:solidFill>
-                  <a:srgbClr val="000000"/>
+                  <a:srgbClr val="111111"/>
                 </a:solidFill>
                 <a:latin typeface="Calibri" pitchFamily="34" charset="0"/>
                 <a:ea typeface="Calibri" pitchFamily="34" charset="-122"/>
@@ -984,14 +982,14 @@
           <a:p>
             <a:pPr algn="ctr" indent="0" marL="0">
               <a:lnSpc>
-                <a:spcPct val="108000"/>
+                <a:spcPct val="110000"/>
               </a:lnSpc>
               <a:buNone/>
             </a:pPr>
             <a:r>
-              <a:rPr lang="en-US" sz="1250" dirty="0">
-                <a:solidFill>
-                  <a:srgbClr val="000000"/>
+              <a:rPr lang="en-US" sz="1250" b="1" dirty="0">
+                <a:solidFill>
+                  <a:srgbClr val="111111"/>
                 </a:solidFill>
                 <a:latin typeface="Apple SD Gothic Neo" pitchFamily="34" charset="0"/>
                 <a:ea typeface="Apple SD Gothic Neo" pitchFamily="34" charset="-122"/>
@@ -1004,12 +1002,12 @@
           <a:p>
             <a:pPr algn="ctr" indent="0" marL="0">
               <a:lnSpc>
-                <a:spcPct val="108000"/>
+                <a:spcPct val="110000"/>
               </a:lnSpc>
               <a:buNone/>
             </a:pPr>
             <a:r>
-              <a:rPr lang="en-US" sz="500" dirty="0">
+              <a:rPr lang="en-US" sz="600" dirty="0">
                 <a:solidFill>
                   <a:srgbClr val="000000"/>
                 </a:solidFill>
@@ -1021,14 +1019,14 @@
           <a:p>
             <a:pPr algn="ctr" indent="0" marL="0">
               <a:lnSpc>
-                <a:spcPct val="108000"/>
+                <a:spcPct val="110000"/>
               </a:lnSpc>
               <a:buNone/>
             </a:pPr>
             <a:r>
-              <a:rPr lang="en-US" sz="1050" dirty="0">
-                <a:solidFill>
-                  <a:srgbClr val="000000"/>
+              <a:rPr lang="en-US" sz="1100" dirty="0">
+                <a:solidFill>
+                  <a:srgbClr val="7A7A7A"/>
                 </a:solidFill>
                 <a:latin typeface="Calibri" pitchFamily="34" charset="0"/>
                 <a:ea typeface="Calibri" pitchFamily="34" charset="-122"/>
@@ -1048,20 +1046,18 @@
         </p:nvSpPr>
         <p:spPr>
           <a:xfrm>
-            <a:off x="6830568" y="1234440"/>
+            <a:off x="6629400" y="1234440"/>
             <a:ext cx="4480560" cy="2103120"/>
           </a:xfrm>
-          <a:prstGeom prst="roundRect">
-            <a:avLst>
-              <a:gd name="adj" fmla="val 3478"/>
-            </a:avLst>
+          <a:prstGeom prst="rect">
+            <a:avLst/>
           </a:prstGeom>
           <a:solidFill>
             <a:srgbClr val="FFFFFF"/>
           </a:solidFill>
-          <a:ln w="25400">
+          <a:ln w="12700">
             <a:solidFill>
-              <a:srgbClr val="000000"/>
+              <a:srgbClr val="9A9A9A"/>
             </a:solidFill>
             <a:prstDash val="solid"/>
           </a:ln>
@@ -1075,7 +1071,7 @@
         </p:nvSpPr>
         <p:spPr>
           <a:xfrm>
-            <a:off x="6830568" y="1234440"/>
+            <a:off x="6629400" y="1234440"/>
             <a:ext cx="4480560" cy="2103120"/>
           </a:xfrm>
           <a:prstGeom prst="rect">
@@ -1090,34 +1086,34 @@
           <a:p>
             <a:pPr algn="ctr" indent="0" marL="0">
               <a:lnSpc>
-                <a:spcPct val="108000"/>
+                <a:spcPct val="110000"/>
               </a:lnSpc>
               <a:buNone/>
             </a:pPr>
             <a:r>
               <a:rPr lang="en-US" sz="1700" b="1" dirty="0">
                 <a:solidFill>
-                  <a:srgbClr val="000000"/>
+                  <a:srgbClr val="111111"/>
                 </a:solidFill>
                 <a:latin typeface="Calibri" pitchFamily="34" charset="0"/>
                 <a:ea typeface="Calibri" pitchFamily="34" charset="-122"/>
                 <a:cs typeface="Calibri" pitchFamily="34" charset="-120"/>
               </a:rPr>
-              <a:t>Safe · Efficient</a:t>
+              <a:t>Efficient · Safe</a:t>
             </a:r>
             <a:endParaRPr lang="en-US" sz="1700" dirty="0"/>
           </a:p>
           <a:p>
             <a:pPr algn="ctr" indent="0" marL="0">
               <a:lnSpc>
-                <a:spcPct val="108000"/>
+                <a:spcPct val="110000"/>
               </a:lnSpc>
               <a:buNone/>
             </a:pPr>
             <a:r>
-              <a:rPr lang="en-US" sz="1250" dirty="0">
-                <a:solidFill>
-                  <a:srgbClr val="000000"/>
+              <a:rPr lang="en-US" sz="1250" b="1" dirty="0">
+                <a:solidFill>
+                  <a:srgbClr val="111111"/>
                 </a:solidFill>
                 <a:latin typeface="Apple SD Gothic Neo" pitchFamily="34" charset="0"/>
                 <a:ea typeface="Apple SD Gothic Neo" pitchFamily="34" charset="-122"/>
@@ -1130,12 +1126,12 @@
           <a:p>
             <a:pPr algn="ctr" indent="0" marL="0">
               <a:lnSpc>
-                <a:spcPct val="108000"/>
+                <a:spcPct val="110000"/>
               </a:lnSpc>
               <a:buNone/>
             </a:pPr>
             <a:r>
-              <a:rPr lang="en-US" sz="500" dirty="0">
+              <a:rPr lang="en-US" sz="600" dirty="0">
                 <a:solidFill>
                   <a:srgbClr val="000000"/>
                 </a:solidFill>
@@ -1147,14 +1143,14 @@
           <a:p>
             <a:pPr algn="ctr" indent="0" marL="0">
               <a:lnSpc>
-                <a:spcPct val="108000"/>
+                <a:spcPct val="110000"/>
               </a:lnSpc>
               <a:buNone/>
             </a:pPr>
             <a:r>
-              <a:rPr lang="en-US" sz="1050" dirty="0">
-                <a:solidFill>
-                  <a:srgbClr val="000000"/>
+              <a:rPr lang="en-US" sz="1100" dirty="0">
+                <a:solidFill>
+                  <a:srgbClr val="7A7A7A"/>
                 </a:solidFill>
                 <a:latin typeface="Calibri" pitchFamily="34" charset="0"/>
                 <a:ea typeface="Calibri" pitchFamily="34" charset="-122"/>
@@ -1174,20 +1170,18 @@
         </p:nvSpPr>
         <p:spPr>
           <a:xfrm>
-            <a:off x="2148840" y="3538728"/>
+            <a:off x="2148840" y="3337560"/>
             <a:ext cx="4480560" cy="2103120"/>
           </a:xfrm>
-          <a:prstGeom prst="roundRect">
-            <a:avLst>
-              <a:gd name="adj" fmla="val 3478"/>
-            </a:avLst>
-          </a:prstGeom>
-          <a:solidFill>
-            <a:srgbClr val="D0D0D0"/>
-          </a:solidFill>
-          <a:ln w="25400">
+          <a:prstGeom prst="rect">
+            <a:avLst/>
+          </a:prstGeom>
+          <a:solidFill>
+            <a:srgbClr val="CFCFCF"/>
+          </a:solidFill>
+          <a:ln w="12700">
             <a:solidFill>
-              <a:srgbClr val="000000"/>
+              <a:srgbClr val="9A9A9A"/>
             </a:solidFill>
             <a:prstDash val="solid"/>
           </a:ln>
@@ -1201,7 +1195,7 @@
         </p:nvSpPr>
         <p:spPr>
           <a:xfrm>
-            <a:off x="2148840" y="3538728"/>
+            <a:off x="2148840" y="3337560"/>
             <a:ext cx="4480560" cy="2103120"/>
           </a:xfrm>
           <a:prstGeom prst="rect">
@@ -1216,14 +1210,14 @@
           <a:p>
             <a:pPr algn="ctr" indent="0" marL="0">
               <a:lnSpc>
-                <a:spcPct val="108000"/>
+                <a:spcPct val="110000"/>
               </a:lnSpc>
               <a:buNone/>
             </a:pPr>
             <a:r>
               <a:rPr lang="en-US" sz="1700" b="1" dirty="0">
                 <a:solidFill>
-                  <a:srgbClr val="000000"/>
+                  <a:srgbClr val="111111"/>
                 </a:solidFill>
                 <a:latin typeface="Calibri" pitchFamily="34" charset="0"/>
                 <a:ea typeface="Calibri" pitchFamily="34" charset="-122"/>
@@ -1236,14 +1230,14 @@
           <a:p>
             <a:pPr algn="ctr" indent="0" marL="0">
               <a:lnSpc>
-                <a:spcPct val="108000"/>
+                <a:spcPct val="110000"/>
               </a:lnSpc>
               <a:buNone/>
             </a:pPr>
             <a:r>
-              <a:rPr lang="en-US" sz="1250" dirty="0">
-                <a:solidFill>
-                  <a:srgbClr val="000000"/>
+              <a:rPr lang="en-US" sz="1250" b="1" dirty="0">
+                <a:solidFill>
+                  <a:srgbClr val="111111"/>
                 </a:solidFill>
                 <a:latin typeface="Apple SD Gothic Neo" pitchFamily="34" charset="0"/>
                 <a:ea typeface="Apple SD Gothic Neo" pitchFamily="34" charset="-122"/>
@@ -1256,12 +1250,12 @@
           <a:p>
             <a:pPr algn="ctr" indent="0" marL="0">
               <a:lnSpc>
-                <a:spcPct val="108000"/>
+                <a:spcPct val="110000"/>
               </a:lnSpc>
               <a:buNone/>
             </a:pPr>
             <a:r>
-              <a:rPr lang="en-US" sz="500" dirty="0">
+              <a:rPr lang="en-US" sz="600" dirty="0">
                 <a:solidFill>
                   <a:srgbClr val="000000"/>
                 </a:solidFill>
@@ -1273,14 +1267,14 @@
           <a:p>
             <a:pPr algn="ctr" indent="0" marL="0">
               <a:lnSpc>
-                <a:spcPct val="108000"/>
+                <a:spcPct val="110000"/>
               </a:lnSpc>
               <a:buNone/>
             </a:pPr>
             <a:r>
-              <a:rPr lang="en-US" sz="1050" dirty="0">
-                <a:solidFill>
-                  <a:srgbClr val="000000"/>
+              <a:rPr lang="en-US" sz="1100" dirty="0">
+                <a:solidFill>
+                  <a:srgbClr val="7A7A7A"/>
                 </a:solidFill>
                 <a:latin typeface="Calibri" pitchFamily="34" charset="0"/>
                 <a:ea typeface="Calibri" pitchFamily="34" charset="-122"/>
@@ -1300,20 +1294,18 @@
         </p:nvSpPr>
         <p:spPr>
           <a:xfrm>
-            <a:off x="6830568" y="3538728"/>
+            <a:off x="6629400" y="3337560"/>
             <a:ext cx="4480560" cy="2103120"/>
           </a:xfrm>
-          <a:prstGeom prst="roundRect">
-            <a:avLst>
-              <a:gd name="adj" fmla="val 3478"/>
-            </a:avLst>
-          </a:prstGeom>
-          <a:solidFill>
-            <a:srgbClr val="EFEFEF"/>
-          </a:solidFill>
-          <a:ln w="25400">
+          <a:prstGeom prst="rect">
+            <a:avLst/>
+          </a:prstGeom>
+          <a:solidFill>
+            <a:srgbClr val="EDEDED"/>
+          </a:solidFill>
+          <a:ln w="12700">
             <a:solidFill>
-              <a:srgbClr val="000000"/>
+              <a:srgbClr val="9A9A9A"/>
             </a:solidFill>
             <a:prstDash val="solid"/>
           </a:ln>
@@ -1327,7 +1319,7 @@
         </p:nvSpPr>
         <p:spPr>
           <a:xfrm>
-            <a:off x="6830568" y="3538728"/>
+            <a:off x="6629400" y="3337560"/>
             <a:ext cx="4480560" cy="2103120"/>
           </a:xfrm>
           <a:prstGeom prst="rect">
@@ -1342,34 +1334,34 @@
           <a:p>
             <a:pPr algn="ctr" indent="0" marL="0">
               <a:lnSpc>
-                <a:spcPct val="108000"/>
+                <a:spcPct val="110000"/>
               </a:lnSpc>
               <a:buNone/>
             </a:pPr>
             <a:r>
               <a:rPr lang="en-US" sz="1700" b="1" dirty="0">
                 <a:solidFill>
-                  <a:srgbClr val="000000"/>
+                  <a:srgbClr val="111111"/>
                 </a:solidFill>
                 <a:latin typeface="Calibri" pitchFamily="34" charset="0"/>
                 <a:ea typeface="Calibri" pitchFamily="34" charset="-122"/>
                 <a:cs typeface="Calibri" pitchFamily="34" charset="-120"/>
               </a:rPr>
-              <a:t>Unsafe · Efficient</a:t>
+              <a:t>Efficient · Unsafe</a:t>
             </a:r>
             <a:endParaRPr lang="en-US" sz="1700" dirty="0"/>
           </a:p>
           <a:p>
             <a:pPr algn="ctr" indent="0" marL="0">
               <a:lnSpc>
-                <a:spcPct val="108000"/>
+                <a:spcPct val="110000"/>
               </a:lnSpc>
               <a:buNone/>
             </a:pPr>
             <a:r>
-              <a:rPr lang="en-US" sz="1250" dirty="0">
-                <a:solidFill>
-                  <a:srgbClr val="000000"/>
+              <a:rPr lang="en-US" sz="1250" b="1" dirty="0">
+                <a:solidFill>
+                  <a:srgbClr val="111111"/>
                 </a:solidFill>
                 <a:latin typeface="Apple SD Gothic Neo" pitchFamily="34" charset="0"/>
                 <a:ea typeface="Apple SD Gothic Neo" pitchFamily="34" charset="-122"/>
@@ -1382,12 +1374,12 @@
           <a:p>
             <a:pPr algn="ctr" indent="0" marL="0">
               <a:lnSpc>
-                <a:spcPct val="108000"/>
+                <a:spcPct val="110000"/>
               </a:lnSpc>
               <a:buNone/>
             </a:pPr>
             <a:r>
-              <a:rPr lang="en-US" sz="500" dirty="0">
+              <a:rPr lang="en-US" sz="600" dirty="0">
                 <a:solidFill>
                   <a:srgbClr val="000000"/>
                 </a:solidFill>
@@ -1399,14 +1391,14 @@
           <a:p>
             <a:pPr algn="ctr" indent="0" marL="0">
               <a:lnSpc>
-                <a:spcPct val="108000"/>
+                <a:spcPct val="110000"/>
               </a:lnSpc>
               <a:buNone/>
             </a:pPr>
             <a:r>
-              <a:rPr lang="en-US" sz="1050" dirty="0">
-                <a:solidFill>
-                  <a:srgbClr val="000000"/>
+              <a:rPr lang="en-US" sz="1100" dirty="0">
+                <a:solidFill>
+                  <a:srgbClr val="7A7A7A"/>
                 </a:solidFill>
                 <a:latin typeface="Calibri" pitchFamily="34" charset="0"/>
                 <a:ea typeface="Calibri" pitchFamily="34" charset="-122"/>
@@ -1416,38 +1408,57 @@
             </a:r>
             <a:endParaRPr lang="en-US" sz="1700" dirty="0"/>
           </a:p>
-          <a:p>
-            <a:pPr algn="ctr" indent="0" marL="0">
-              <a:lnSpc>
-                <a:spcPct val="108000"/>
-              </a:lnSpc>
-              <a:buNone/>
-            </a:pPr>
-            <a:r>
-              <a:rPr lang="en-US" sz="1050" dirty="0">
-                <a:solidFill>
-                  <a:srgbClr val="000000"/>
+        </p:txBody>
+      </p:sp>
+      <p:sp>
+        <p:nvSpPr>
+          <p:cNvPr id="11" name="Text 9"/>
+          <p:cNvSpPr/>
+          <p:nvPr/>
+        </p:nvSpPr>
+        <p:spPr>
+          <a:xfrm>
+            <a:off x="1051560" y="1234440"/>
+            <a:ext cx="960120" cy="2103120"/>
+          </a:xfrm>
+          <a:prstGeom prst="rect">
+            <a:avLst/>
+          </a:prstGeom>
+          <a:noFill/>
+          <a:ln/>
+        </p:spPr>
+        <p:txBody>
+          <a:bodyPr wrap="square" rtlCol="0" anchor="ctr"/>
+          <a:lstStyle/>
+          <a:p>
+            <a:pPr algn="r" indent="0" marL="0">
+              <a:buNone/>
+            </a:pPr>
+            <a:r>
+              <a:rPr lang="en-US" sz="1300" dirty="0">
+                <a:solidFill>
+                  <a:srgbClr val="6F6F6F"/>
                 </a:solidFill>
                 <a:latin typeface="Calibri" pitchFamily="34" charset="0"/>
                 <a:ea typeface="Calibri" pitchFamily="34" charset="-122"/>
                 <a:cs typeface="Calibri" pitchFamily="34" charset="-120"/>
               </a:rPr>
-              <a:t>(danger from capability, not incompetence)</a:t>
-            </a:r>
-            <a:endParaRPr lang="en-US" sz="1700" dirty="0"/>
+              <a:t>Safe</a:t>
+            </a:r>
+            <a:endParaRPr lang="en-US" sz="1300" dirty="0"/>
           </a:p>
         </p:txBody>
       </p:sp>
       <p:sp>
         <p:nvSpPr>
-          <p:cNvPr id="11" name="Text 9"/>
+          <p:cNvPr id="12" name="Text 10"/>
           <p:cNvSpPr/>
           <p:nvPr/>
         </p:nvSpPr>
         <p:spPr>
           <a:xfrm>
-            <a:off x="1051560" y="1234440"/>
-            <a:ext cx="960120" cy="2103120"/>
+            <a:off x="960120" y="3337560"/>
+            <a:ext cx="1051560" cy="2103120"/>
           </a:xfrm>
           <a:prstGeom prst="rect">
             <a:avLst/>
@@ -1463,30 +1474,30 @@
               <a:buNone/>
             </a:pPr>
             <a:r>
-              <a:rPr lang="en-US" sz="1400" b="1" dirty="0">
-                <a:solidFill>
-                  <a:srgbClr val="000000"/>
+              <a:rPr lang="en-US" sz="1300" dirty="0">
+                <a:solidFill>
+                  <a:srgbClr val="6F6F6F"/>
                 </a:solidFill>
                 <a:latin typeface="Calibri" pitchFamily="34" charset="0"/>
                 <a:ea typeface="Calibri" pitchFamily="34" charset="-122"/>
                 <a:cs typeface="Calibri" pitchFamily="34" charset="-120"/>
               </a:rPr>
-              <a:t>Safe</a:t>
-            </a:r>
-            <a:endParaRPr lang="en-US" sz="1400" dirty="0"/>
+              <a:t>Unsafe</a:t>
+            </a:r>
+            <a:endParaRPr lang="en-US" sz="1300" dirty="0"/>
           </a:p>
         </p:txBody>
       </p:sp>
       <p:sp>
         <p:nvSpPr>
-          <p:cNvPr id="12" name="Text 10"/>
+          <p:cNvPr id="13" name="Text 11"/>
           <p:cNvSpPr/>
           <p:nvPr/>
         </p:nvSpPr>
         <p:spPr>
-          <a:xfrm>
-            <a:off x="960120" y="3538728"/>
-            <a:ext cx="1051560" cy="2103120"/>
+          <a:xfrm rot="16200000">
+            <a:off x="-1234440" y="3063240"/>
+            <a:ext cx="3931920" cy="457200"/>
           </a:xfrm>
           <a:prstGeom prst="rect">
             <a:avLst/>
@@ -1498,11 +1509,11 @@
           <a:bodyPr wrap="square" rtlCol="0" anchor="ctr"/>
           <a:lstStyle/>
           <a:p>
-            <a:pPr algn="r" indent="0" marL="0">
-              <a:buNone/>
-            </a:pPr>
-            <a:r>
-              <a:rPr lang="en-US" sz="1400" b="1" dirty="0">
+            <a:pPr algn="ctr" indent="0" marL="0">
+              <a:buNone/>
+            </a:pPr>
+            <a:r>
+              <a:rPr lang="en-US" sz="1500" b="1" dirty="0">
                 <a:solidFill>
                   <a:srgbClr val="000000"/>
                 </a:solidFill>
@@ -1510,22 +1521,22 @@
                 <a:ea typeface="Calibri" pitchFamily="34" charset="-122"/>
                 <a:cs typeface="Calibri" pitchFamily="34" charset="-120"/>
               </a:rPr>
-              <a:t>Unsafe</a:t>
-            </a:r>
-            <a:endParaRPr lang="en-US" sz="1400" dirty="0"/>
+              <a:t>Safety (Harmlessness)</a:t>
+            </a:r>
+            <a:endParaRPr lang="en-US" sz="1500" dirty="0"/>
           </a:p>
         </p:txBody>
       </p:sp>
       <p:sp>
         <p:nvSpPr>
-          <p:cNvPr id="13" name="Text 11"/>
+          <p:cNvPr id="14" name="Text 12"/>
           <p:cNvSpPr/>
           <p:nvPr/>
         </p:nvSpPr>
         <p:spPr>
-          <a:xfrm rot="16200000">
-            <a:off x="-1234440" y="3063240"/>
-            <a:ext cx="3931920" cy="457200"/>
+          <a:xfrm>
+            <a:off x="2148840" y="5495544"/>
+            <a:ext cx="4480560" cy="365760"/>
           </a:xfrm>
           <a:prstGeom prst="rect">
             <a:avLst/>
@@ -1541,7 +1552,7 @@
               <a:buNone/>
             </a:pPr>
             <a:r>
-              <a:rPr lang="en-US" sz="1500" b="1" dirty="0">
+              <a:rPr lang="en-US" sz="1400" b="1" dirty="0">
                 <a:solidFill>
                   <a:srgbClr val="000000"/>
                 </a:solidFill>
@@ -1549,21 +1560,21 @@
                 <a:ea typeface="Calibri" pitchFamily="34" charset="-122"/>
                 <a:cs typeface="Calibri" pitchFamily="34" charset="-120"/>
               </a:rPr>
-              <a:t>Safety (Harmlessness)</a:t>
-            </a:r>
-            <a:endParaRPr lang="en-US" sz="1500" dirty="0"/>
+              <a:t>Inefficient</a:t>
+            </a:r>
+            <a:endParaRPr lang="en-US" sz="1400" dirty="0"/>
           </a:p>
         </p:txBody>
       </p:sp>
       <p:sp>
         <p:nvSpPr>
-          <p:cNvPr id="14" name="Text 12"/>
+          <p:cNvPr id="15" name="Text 13"/>
           <p:cNvSpPr/>
           <p:nvPr/>
         </p:nvSpPr>
         <p:spPr>
           <a:xfrm>
-            <a:off x="2148840" y="5696712"/>
+            <a:off x="6629400" y="5495544"/>
             <a:ext cx="4480560" cy="365760"/>
           </a:xfrm>
           <a:prstGeom prst="rect">
@@ -1588,7 +1599,7 @@
                 <a:ea typeface="Calibri" pitchFamily="34" charset="-122"/>
                 <a:cs typeface="Calibri" pitchFamily="34" charset="-120"/>
               </a:rPr>
-              <a:t>Inefficient</a:t>
+              <a:t>Efficient</a:t>
             </a:r>
             <a:endParaRPr lang="en-US" sz="1400" dirty="0"/>
           </a:p>
@@ -1596,14 +1607,14 @@
       </p:sp>
       <p:sp>
         <p:nvSpPr>
-          <p:cNvPr id="15" name="Text 13"/>
+          <p:cNvPr id="16" name="Text 14"/>
           <p:cNvSpPr/>
           <p:nvPr/>
         </p:nvSpPr>
         <p:spPr>
           <a:xfrm>
-            <a:off x="6830568" y="5696712"/>
-            <a:ext cx="4480560" cy="365760"/>
+            <a:off x="2148840" y="5879592"/>
+            <a:ext cx="8961120" cy="365760"/>
           </a:xfrm>
           <a:prstGeom prst="rect">
             <a:avLst/>
@@ -1619,7 +1630,7 @@
               <a:buNone/>
             </a:pPr>
             <a:r>
-              <a:rPr lang="en-US" sz="1400" b="1" dirty="0">
+              <a:rPr lang="en-US" sz="1500" b="1" dirty="0">
                 <a:solidFill>
                   <a:srgbClr val="000000"/>
                 </a:solidFill>
@@ -1627,45 +1638,6 @@
                 <a:ea typeface="Calibri" pitchFamily="34" charset="-122"/>
                 <a:cs typeface="Calibri" pitchFamily="34" charset="-120"/>
               </a:rPr>
-              <a:t>Efficient</a:t>
-            </a:r>
-            <a:endParaRPr lang="en-US" sz="1400" dirty="0"/>
-          </a:p>
-        </p:txBody>
-      </p:sp>
-      <p:sp>
-        <p:nvSpPr>
-          <p:cNvPr id="16" name="Text 14"/>
-          <p:cNvSpPr/>
-          <p:nvPr/>
-        </p:nvSpPr>
-        <p:spPr>
-          <a:xfrm>
-            <a:off x="2148840" y="6080760"/>
-            <a:ext cx="9162288" cy="365760"/>
-          </a:xfrm>
-          <a:prstGeom prst="rect">
-            <a:avLst/>
-          </a:prstGeom>
-          <a:noFill/>
-          <a:ln/>
-        </p:spPr>
-        <p:txBody>
-          <a:bodyPr wrap="square" rtlCol="0" anchor="ctr"/>
-          <a:lstStyle/>
-          <a:p>
-            <a:pPr algn="ctr" indent="0" marL="0">
-              <a:buNone/>
-            </a:pPr>
-            <a:r>
-              <a:rPr lang="en-US" sz="1500" b="1" dirty="0">
-                <a:solidFill>
-                  <a:srgbClr val="000000"/>
-                </a:solidFill>
-                <a:latin typeface="Calibri" pitchFamily="34" charset="0"/>
-                <a:ea typeface="Calibri" pitchFamily="34" charset="-122"/>
-                <a:cs typeface="Calibri" pitchFamily="34" charset="-120"/>
-              </a:rPr>
               <a:t>Task Efficiency  ( ↓ time, ↓ energy )</a:t>
             </a:r>
             <a:endParaRPr lang="en-US" sz="1500" dirty="0"/>
@@ -1680,8 +1652,8 @@
         </p:nvSpPr>
         <p:spPr>
           <a:xfrm>
-            <a:off x="1691640" y="6473952"/>
-            <a:ext cx="10076688" cy="320040"/>
+            <a:off x="1691640" y="6272784"/>
+            <a:ext cx="9875520" cy="320040"/>
           </a:xfrm>
           <a:prstGeom prst="rect">
             <a:avLst/>

</xml_diff>

<commit_message>
Finalize H1-H2 trade-off matrix (H1/H2 axis labels, gray parenthesized KR, slate Unsafe-Inefficient cell)
</commit_message>
<xml_diff>
--- a/output/guardrail_matrix.pptx
+++ b/output/guardrail_matrix.pptx
@@ -883,7 +883,7 @@
         </p:nvSpPr>
         <p:spPr>
           <a:xfrm>
-            <a:off x="365760" y="201168"/>
+            <a:off x="365760" y="256032"/>
             <a:ext cx="11457432" cy="640080"/>
           </a:xfrm>
           <a:prstGeom prst="rect">
@@ -902,13 +902,13 @@
             <a:r>
               <a:rPr lang="en-US" sz="2400" b="1" dirty="0">
                 <a:solidFill>
-                  <a:srgbClr val="000000"/>
+                  <a:srgbClr val="111111"/>
                 </a:solidFill>
                 <a:latin typeface="Calibri" pitchFamily="34" charset="0"/>
                 <a:ea typeface="Calibri" pitchFamily="34" charset="-122"/>
                 <a:cs typeface="Calibri" pitchFamily="34" charset="-120"/>
               </a:rPr>
-              <a:t>Harmless and Helpful Tradeoff - Physical AI Actions</a:t>
+              <a:t>H1 and H2 Tradeoff - Physical AI Actions</a:t>
             </a:r>
             <a:endParaRPr lang="en-US" sz="2400" dirty="0"/>
           </a:p>
@@ -922,8 +922,8 @@
         </p:nvSpPr>
         <p:spPr>
           <a:xfrm>
-            <a:off x="2148840" y="1234440"/>
-            <a:ext cx="4480560" cy="2103120"/>
+            <a:off x="2331720" y="1325880"/>
+            <a:ext cx="4434840" cy="2057400"/>
           </a:xfrm>
           <a:prstGeom prst="rect">
             <a:avLst/>
@@ -947,8 +947,8 @@
         </p:nvSpPr>
         <p:spPr>
           <a:xfrm>
-            <a:off x="2148840" y="1234440"/>
-            <a:ext cx="4480560" cy="2103120"/>
+            <a:off x="2331720" y="1325880"/>
+            <a:ext cx="4434840" cy="2057400"/>
           </a:xfrm>
           <a:prstGeom prst="rect">
             <a:avLst/>
@@ -962,7 +962,7 @@
           <a:p>
             <a:pPr algn="ctr" indent="0" marL="0">
               <a:lnSpc>
-                <a:spcPct val="110000"/>
+                <a:spcPct val="112000"/>
               </a:lnSpc>
               <a:buNone/>
             </a:pPr>
@@ -982,32 +982,32 @@
           <a:p>
             <a:pPr algn="ctr" indent="0" marL="0">
               <a:lnSpc>
-                <a:spcPct val="110000"/>
+                <a:spcPct val="112000"/>
               </a:lnSpc>
               <a:buNone/>
             </a:pPr>
             <a:r>
-              <a:rPr lang="en-US" sz="1250" b="1" dirty="0">
-                <a:solidFill>
-                  <a:srgbClr val="111111"/>
+              <a:rPr lang="en-US" sz="1250" dirty="0">
+                <a:solidFill>
+                  <a:srgbClr val="7A7A7A"/>
                 </a:solidFill>
                 <a:latin typeface="Apple SD Gothic Neo" pitchFamily="34" charset="0"/>
                 <a:ea typeface="Apple SD Gothic Neo" pitchFamily="34" charset="-122"/>
                 <a:cs typeface="Apple SD Gothic Neo" pitchFamily="34" charset="-120"/>
               </a:rPr>
-              <a:t>안전하나 비효율적</a:t>
+              <a:t>(안전하나 비효율적)</a:t>
             </a:r>
             <a:endParaRPr lang="en-US" sz="1700" dirty="0"/>
           </a:p>
           <a:p>
             <a:pPr algn="ctr" indent="0" marL="0">
               <a:lnSpc>
-                <a:spcPct val="110000"/>
+                <a:spcPct val="112000"/>
               </a:lnSpc>
               <a:buNone/>
             </a:pPr>
             <a:r>
-              <a:rPr lang="en-US" sz="600" dirty="0">
+              <a:rPr lang="en-US" sz="800" dirty="0">
                 <a:solidFill>
                   <a:srgbClr val="000000"/>
                 </a:solidFill>
@@ -1019,7 +1019,7 @@
           <a:p>
             <a:pPr algn="ctr" indent="0" marL="0">
               <a:lnSpc>
-                <a:spcPct val="110000"/>
+                <a:spcPct val="112000"/>
               </a:lnSpc>
               <a:buNone/>
             </a:pPr>
@@ -1046,8 +1046,8 @@
         </p:nvSpPr>
         <p:spPr>
           <a:xfrm>
-            <a:off x="6629400" y="1234440"/>
-            <a:ext cx="4480560" cy="2103120"/>
+            <a:off x="6766560" y="1325880"/>
+            <a:ext cx="4434840" cy="2057400"/>
           </a:xfrm>
           <a:prstGeom prst="rect">
             <a:avLst/>
@@ -1071,8 +1071,8 @@
         </p:nvSpPr>
         <p:spPr>
           <a:xfrm>
-            <a:off x="6629400" y="1234440"/>
-            <a:ext cx="4480560" cy="2103120"/>
+            <a:off x="6766560" y="1325880"/>
+            <a:ext cx="4434840" cy="2057400"/>
           </a:xfrm>
           <a:prstGeom prst="rect">
             <a:avLst/>
@@ -1086,7 +1086,7 @@
           <a:p>
             <a:pPr algn="ctr" indent="0" marL="0">
               <a:lnSpc>
-                <a:spcPct val="110000"/>
+                <a:spcPct val="112000"/>
               </a:lnSpc>
               <a:buNone/>
             </a:pPr>
@@ -1106,32 +1106,32 @@
           <a:p>
             <a:pPr algn="ctr" indent="0" marL="0">
               <a:lnSpc>
-                <a:spcPct val="110000"/>
+                <a:spcPct val="112000"/>
               </a:lnSpc>
               <a:buNone/>
             </a:pPr>
             <a:r>
-              <a:rPr lang="en-US" sz="1250" b="1" dirty="0">
-                <a:solidFill>
-                  <a:srgbClr val="111111"/>
+              <a:rPr lang="en-US" sz="1250" dirty="0">
+                <a:solidFill>
+                  <a:srgbClr val="7A7A7A"/>
                 </a:solidFill>
                 <a:latin typeface="Apple SD Gothic Neo" pitchFamily="34" charset="0"/>
                 <a:ea typeface="Apple SD Gothic Neo" pitchFamily="34" charset="-122"/>
                 <a:cs typeface="Apple SD Gothic Neo" pitchFamily="34" charset="-120"/>
               </a:rPr>
-              <a:t>효율적이고 안전한</a:t>
+              <a:t>(효율적이고 안전한)</a:t>
             </a:r>
             <a:endParaRPr lang="en-US" sz="1700" dirty="0"/>
           </a:p>
           <a:p>
             <a:pPr algn="ctr" indent="0" marL="0">
               <a:lnSpc>
-                <a:spcPct val="110000"/>
+                <a:spcPct val="112000"/>
               </a:lnSpc>
               <a:buNone/>
             </a:pPr>
             <a:r>
-              <a:rPr lang="en-US" sz="600" dirty="0">
+              <a:rPr lang="en-US" sz="800" dirty="0">
                 <a:solidFill>
                   <a:srgbClr val="000000"/>
                 </a:solidFill>
@@ -1143,7 +1143,7 @@
           <a:p>
             <a:pPr algn="ctr" indent="0" marL="0">
               <a:lnSpc>
-                <a:spcPct val="110000"/>
+                <a:spcPct val="112000"/>
               </a:lnSpc>
               <a:buNone/>
             </a:pPr>
@@ -1170,14 +1170,14 @@
         </p:nvSpPr>
         <p:spPr>
           <a:xfrm>
-            <a:off x="2148840" y="3337560"/>
-            <a:ext cx="4480560" cy="2103120"/>
-          </a:xfrm>
-          <a:prstGeom prst="rect">
-            <a:avLst/>
-          </a:prstGeom>
-          <a:solidFill>
-            <a:srgbClr val="CFCFCF"/>
+            <a:off x="2331720" y="3383280"/>
+            <a:ext cx="4434840" cy="2057400"/>
+          </a:xfrm>
+          <a:prstGeom prst="rect">
+            <a:avLst/>
+          </a:prstGeom>
+          <a:solidFill>
+            <a:srgbClr val="C4CAD6"/>
           </a:solidFill>
           <a:ln w="12700">
             <a:solidFill>
@@ -1195,8 +1195,8 @@
         </p:nvSpPr>
         <p:spPr>
           <a:xfrm>
-            <a:off x="2148840" y="3337560"/>
-            <a:ext cx="4480560" cy="2103120"/>
+            <a:off x="2331720" y="3383280"/>
+            <a:ext cx="4434840" cy="2057400"/>
           </a:xfrm>
           <a:prstGeom prst="rect">
             <a:avLst/>
@@ -1210,7 +1210,7 @@
           <a:p>
             <a:pPr algn="ctr" indent="0" marL="0">
               <a:lnSpc>
-                <a:spcPct val="110000"/>
+                <a:spcPct val="112000"/>
               </a:lnSpc>
               <a:buNone/>
             </a:pPr>
@@ -1230,32 +1230,32 @@
           <a:p>
             <a:pPr algn="ctr" indent="0" marL="0">
               <a:lnSpc>
-                <a:spcPct val="110000"/>
+                <a:spcPct val="112000"/>
               </a:lnSpc>
               <a:buNone/>
             </a:pPr>
             <a:r>
-              <a:rPr lang="en-US" sz="1250" b="1" dirty="0">
-                <a:solidFill>
-                  <a:srgbClr val="111111"/>
+              <a:rPr lang="en-US" sz="1250" dirty="0">
+                <a:solidFill>
+                  <a:srgbClr val="7A7A7A"/>
                 </a:solidFill>
                 <a:latin typeface="Apple SD Gothic Neo" pitchFamily="34" charset="0"/>
                 <a:ea typeface="Apple SD Gothic Neo" pitchFamily="34" charset="-122"/>
                 <a:cs typeface="Apple SD Gothic Neo" pitchFamily="34" charset="-120"/>
               </a:rPr>
-              <a:t>위험하고 비효율적</a:t>
+              <a:t>(위험하고 비효율적)</a:t>
             </a:r>
             <a:endParaRPr lang="en-US" sz="1700" dirty="0"/>
           </a:p>
           <a:p>
             <a:pPr algn="ctr" indent="0" marL="0">
               <a:lnSpc>
-                <a:spcPct val="110000"/>
+                <a:spcPct val="112000"/>
               </a:lnSpc>
               <a:buNone/>
             </a:pPr>
             <a:r>
-              <a:rPr lang="en-US" sz="600" dirty="0">
+              <a:rPr lang="en-US" sz="800" dirty="0">
                 <a:solidFill>
                   <a:srgbClr val="000000"/>
                 </a:solidFill>
@@ -1267,7 +1267,7 @@
           <a:p>
             <a:pPr algn="ctr" indent="0" marL="0">
               <a:lnSpc>
-                <a:spcPct val="110000"/>
+                <a:spcPct val="112000"/>
               </a:lnSpc>
               <a:buNone/>
             </a:pPr>
@@ -1294,8 +1294,8 @@
         </p:nvSpPr>
         <p:spPr>
           <a:xfrm>
-            <a:off x="6629400" y="3337560"/>
-            <a:ext cx="4480560" cy="2103120"/>
+            <a:off x="6766560" y="3383280"/>
+            <a:ext cx="4434840" cy="2057400"/>
           </a:xfrm>
           <a:prstGeom prst="rect">
             <a:avLst/>
@@ -1319,8 +1319,8 @@
         </p:nvSpPr>
         <p:spPr>
           <a:xfrm>
-            <a:off x="6629400" y="3337560"/>
-            <a:ext cx="4480560" cy="2103120"/>
+            <a:off x="6766560" y="3383280"/>
+            <a:ext cx="4434840" cy="2057400"/>
           </a:xfrm>
           <a:prstGeom prst="rect">
             <a:avLst/>
@@ -1334,7 +1334,7 @@
           <a:p>
             <a:pPr algn="ctr" indent="0" marL="0">
               <a:lnSpc>
-                <a:spcPct val="110000"/>
+                <a:spcPct val="112000"/>
               </a:lnSpc>
               <a:buNone/>
             </a:pPr>
@@ -1354,32 +1354,32 @@
           <a:p>
             <a:pPr algn="ctr" indent="0" marL="0">
               <a:lnSpc>
-                <a:spcPct val="110000"/>
+                <a:spcPct val="112000"/>
               </a:lnSpc>
               <a:buNone/>
             </a:pPr>
             <a:r>
-              <a:rPr lang="en-US" sz="1250" b="1" dirty="0">
-                <a:solidFill>
-                  <a:srgbClr val="111111"/>
+              <a:rPr lang="en-US" sz="1250" dirty="0">
+                <a:solidFill>
+                  <a:srgbClr val="7A7A7A"/>
                 </a:solidFill>
                 <a:latin typeface="Apple SD Gothic Neo" pitchFamily="34" charset="0"/>
                 <a:ea typeface="Apple SD Gothic Neo" pitchFamily="34" charset="-122"/>
                 <a:cs typeface="Apple SD Gothic Neo" pitchFamily="34" charset="-120"/>
               </a:rPr>
-              <a:t>효율적이나 위험한</a:t>
+              <a:t>(효율적이나 위험한)</a:t>
             </a:r>
             <a:endParaRPr lang="en-US" sz="1700" dirty="0"/>
           </a:p>
           <a:p>
             <a:pPr algn="ctr" indent="0" marL="0">
               <a:lnSpc>
-                <a:spcPct val="110000"/>
+                <a:spcPct val="112000"/>
               </a:lnSpc>
               <a:buNone/>
             </a:pPr>
             <a:r>
-              <a:rPr lang="en-US" sz="600" dirty="0">
+              <a:rPr lang="en-US" sz="800" dirty="0">
                 <a:solidFill>
                   <a:srgbClr val="000000"/>
                 </a:solidFill>
@@ -1391,7 +1391,7 @@
           <a:p>
             <a:pPr algn="ctr" indent="0" marL="0">
               <a:lnSpc>
-                <a:spcPct val="110000"/>
+                <a:spcPct val="112000"/>
               </a:lnSpc>
               <a:buNone/>
             </a:pPr>
@@ -1418,8 +1418,8 @@
         </p:nvSpPr>
         <p:spPr>
           <a:xfrm>
-            <a:off x="1051560" y="1234440"/>
-            <a:ext cx="960120" cy="2103120"/>
+            <a:off x="1234440" y="1325880"/>
+            <a:ext cx="960120" cy="2057400"/>
           </a:xfrm>
           <a:prstGeom prst="rect">
             <a:avLst/>
@@ -1435,9 +1435,9 @@
               <a:buNone/>
             </a:pPr>
             <a:r>
-              <a:rPr lang="en-US" sz="1300" dirty="0">
-                <a:solidFill>
-                  <a:srgbClr val="6F6F6F"/>
+              <a:rPr lang="en-US" sz="1400" b="1" dirty="0">
+                <a:solidFill>
+                  <a:srgbClr val="111111"/>
                 </a:solidFill>
                 <a:latin typeface="Calibri" pitchFamily="34" charset="0"/>
                 <a:ea typeface="Calibri" pitchFamily="34" charset="-122"/>
@@ -1445,7 +1445,7 @@
               </a:rPr>
               <a:t>Safe</a:t>
             </a:r>
-            <a:endParaRPr lang="en-US" sz="1300" dirty="0"/>
+            <a:endParaRPr lang="en-US" sz="1400" dirty="0"/>
           </a:p>
         </p:txBody>
       </p:sp>
@@ -1457,8 +1457,8 @@
         </p:nvSpPr>
         <p:spPr>
           <a:xfrm>
-            <a:off x="960120" y="3337560"/>
-            <a:ext cx="1051560" cy="2103120"/>
+            <a:off x="1143000" y="3383280"/>
+            <a:ext cx="1051560" cy="2057400"/>
           </a:xfrm>
           <a:prstGeom prst="rect">
             <a:avLst/>
@@ -1474,9 +1474,9 @@
               <a:buNone/>
             </a:pPr>
             <a:r>
-              <a:rPr lang="en-US" sz="1300" dirty="0">
-                <a:solidFill>
-                  <a:srgbClr val="6F6F6F"/>
+              <a:rPr lang="en-US" sz="1400" b="1" dirty="0">
+                <a:solidFill>
+                  <a:srgbClr val="111111"/>
                 </a:solidFill>
                 <a:latin typeface="Calibri" pitchFamily="34" charset="0"/>
                 <a:ea typeface="Calibri" pitchFamily="34" charset="-122"/>
@@ -1484,7 +1484,7 @@
               </a:rPr>
               <a:t>Unsafe</a:t>
             </a:r>
-            <a:endParaRPr lang="en-US" sz="1300" dirty="0"/>
+            <a:endParaRPr lang="en-US" sz="1400" dirty="0"/>
           </a:p>
         </p:txBody>
       </p:sp>
@@ -1496,7 +1496,7 @@
         </p:nvSpPr>
         <p:spPr>
           <a:xfrm rot="16200000">
-            <a:off x="-1234440" y="3063240"/>
+            <a:off x="-1234440" y="3154680"/>
             <a:ext cx="3931920" cy="457200"/>
           </a:xfrm>
           <a:prstGeom prst="rect">
@@ -1515,13 +1515,13 @@
             <a:r>
               <a:rPr lang="en-US" sz="1500" b="1" dirty="0">
                 <a:solidFill>
-                  <a:srgbClr val="000000"/>
+                  <a:srgbClr val="111111"/>
                 </a:solidFill>
                 <a:latin typeface="Calibri" pitchFamily="34" charset="0"/>
                 <a:ea typeface="Calibri" pitchFamily="34" charset="-122"/>
                 <a:cs typeface="Calibri" pitchFamily="34" charset="-120"/>
               </a:rPr>
-              <a:t>Safety (Harmlessness)</a:t>
+              <a:t>H1: Safety</a:t>
             </a:r>
             <a:endParaRPr lang="en-US" sz="1500" dirty="0"/>
           </a:p>
@@ -1535,8 +1535,8 @@
         </p:nvSpPr>
         <p:spPr>
           <a:xfrm>
-            <a:off x="2148840" y="5495544"/>
-            <a:ext cx="4480560" cy="365760"/>
+            <a:off x="2331720" y="5513832"/>
+            <a:ext cx="4434840" cy="365760"/>
           </a:xfrm>
           <a:prstGeom prst="rect">
             <a:avLst/>
@@ -1554,7 +1554,7 @@
             <a:r>
               <a:rPr lang="en-US" sz="1400" b="1" dirty="0">
                 <a:solidFill>
-                  <a:srgbClr val="000000"/>
+                  <a:srgbClr val="111111"/>
                 </a:solidFill>
                 <a:latin typeface="Calibri" pitchFamily="34" charset="0"/>
                 <a:ea typeface="Calibri" pitchFamily="34" charset="-122"/>
@@ -1574,8 +1574,8 @@
         </p:nvSpPr>
         <p:spPr>
           <a:xfrm>
-            <a:off x="6629400" y="5495544"/>
-            <a:ext cx="4480560" cy="365760"/>
+            <a:off x="6766560" y="5513832"/>
+            <a:ext cx="4434840" cy="365760"/>
           </a:xfrm>
           <a:prstGeom prst="rect">
             <a:avLst/>
@@ -1593,7 +1593,7 @@
             <a:r>
               <a:rPr lang="en-US" sz="1400" b="1" dirty="0">
                 <a:solidFill>
-                  <a:srgbClr val="000000"/>
+                  <a:srgbClr val="111111"/>
                 </a:solidFill>
                 <a:latin typeface="Calibri" pitchFamily="34" charset="0"/>
                 <a:ea typeface="Calibri" pitchFamily="34" charset="-122"/>
@@ -1613,8 +1613,8 @@
         </p:nvSpPr>
         <p:spPr>
           <a:xfrm>
-            <a:off x="2148840" y="5879592"/>
-            <a:ext cx="8961120" cy="365760"/>
+            <a:off x="2331720" y="5971032"/>
+            <a:ext cx="8869680" cy="365760"/>
           </a:xfrm>
           <a:prstGeom prst="rect">
             <a:avLst/>
@@ -1632,54 +1632,15 @@
             <a:r>
               <a:rPr lang="en-US" sz="1500" b="1" dirty="0">
                 <a:solidFill>
-                  <a:srgbClr val="000000"/>
+                  <a:srgbClr val="111111"/>
                 </a:solidFill>
                 <a:latin typeface="Calibri" pitchFamily="34" charset="0"/>
                 <a:ea typeface="Calibri" pitchFamily="34" charset="-122"/>
                 <a:cs typeface="Calibri" pitchFamily="34" charset="-120"/>
               </a:rPr>
-              <a:t>Task Efficiency  ( ↓ time, ↓ energy )</a:t>
+              <a:t>H2: Task Efficiency  ( ↓ time, ↓ energy )</a:t>
             </a:r>
             <a:endParaRPr lang="en-US" sz="1500" dirty="0"/>
-          </a:p>
-        </p:txBody>
-      </p:sp>
-      <p:sp>
-        <p:nvSpPr>
-          <p:cNvPr id="17" name="Text 15"/>
-          <p:cNvSpPr/>
-          <p:nvPr/>
-        </p:nvSpPr>
-        <p:spPr>
-          <a:xfrm>
-            <a:off x="1691640" y="6272784"/>
-            <a:ext cx="9875520" cy="320040"/>
-          </a:xfrm>
-          <a:prstGeom prst="rect">
-            <a:avLst/>
-          </a:prstGeom>
-          <a:noFill/>
-          <a:ln/>
-        </p:spPr>
-        <p:txBody>
-          <a:bodyPr wrap="square" rtlCol="0" anchor="ctr"/>
-          <a:lstStyle/>
-          <a:p>
-            <a:pPr algn="ctr" indent="0" marL="0">
-              <a:buNone/>
-            </a:pPr>
-            <a:r>
-              <a:rPr lang="en-US" sz="1000" i="1" dirty="0">
-                <a:solidFill>
-                  <a:srgbClr val="000000"/>
-                </a:solidFill>
-                <a:latin typeface="Calibri" pitchFamily="34" charset="0"/>
-                <a:ea typeface="Calibri" pitchFamily="34" charset="-122"/>
-                <a:cs typeface="Calibri" pitchFamily="34" charset="-120"/>
-              </a:rPr>
-              <a:t>Efficiency is defined given task completion (else minimizing time/energy degenerates to inaction).</a:t>
-            </a:r>
-            <a:endParaRPr lang="en-US" sz="1000" dirty="0"/>
           </a:p>
         </p:txBody>
       </p:sp>

</xml_diff>

<commit_message>
Add Korean L4-mapping workflow figure (updated official counts 3,610,449/416,387/84,912) with PDF/PPTX/PNG exports, dated backup, 1-col/2-col variants; guardrail matrix PPTX; Pages-deploy handover
</commit_message>
<xml_diff>
--- a/output/guardrail_matrix.pptx
+++ b/output/guardrail_matrix.pptx
@@ -4,14 +4,15 @@
   <p:sldMasterIdLst>
     <p:sldMasterId id="2147483648" r:id="rId1"/>
   </p:sldMasterIdLst>
+  <p:notesMasterIdLst>
+    <p:notesMasterId r:id="rId4"/>
+  </p:notesMasterIdLst>
   <p:sldIdLst>
     <p:sldId id="256" r:id="rId2"/>
+    <p:sldId id="257" r:id="rId3"/>
   </p:sldIdLst>
-  <p:notesMasterIdLst>
-    <p:notesMasterId r:id="rId3"/>
-  </p:notesMasterIdLst>
-  <p:sldSz cx="12188952" cy="6858000"/>
-  <p:notesSz cx="6858000" cy="12188952"/>
+  <p:sldSz cx="12188825" cy="6858000"/>
+  <p:notesSz cx="6858000" cy="12188825"/>
   <p:defaultTextStyle>
     <a:lvl1pPr marL="0" algn="l" defTabSz="914400" rtl="0" eaLnBrk="1" latinLnBrk="0" hangingPunct="1">
       <a:defRPr sz="1800" kern="1200">
@@ -104,6 +105,11 @@
       </a:defRPr>
     </a:lvl9pPr>
   </p:defaultTextStyle>
+  <p:extLst>
+    <p:ext uri="{EFAFB233-063F-42B5-8137-9DF3F51BA10A}">
+      <p15:sldGuideLst xmlns:p15="http://schemas.microsoft.com/office/powerpoint/2012/main"/>
+    </p:ext>
+  </p:extLst>
 </p:presentation>
 </file>
 
@@ -129,240 +135,16 @@
           <a:chExt cx="0" cy="0"/>
         </a:xfrm>
       </p:grpSpPr>
-      <p:sp>
-        <p:nvSpPr>
-          <p:cNvPr id="2" name="Header Placeholder 1"/>
-          <p:cNvSpPr>
-            <a:spLocks noGrp="1"/>
-          </p:cNvSpPr>
-          <p:nvPr>
-            <p:ph type="hdr" sz="quarter"/>
-          </p:nvPr>
-        </p:nvSpPr>
-        <p:spPr>
-          <a:xfrm>
-            <a:off x="0" y="0"/>
-            <a:ext cx="2971800" cy="458788"/>
-          </a:xfrm>
-          <a:prstGeom prst="rect">
-            <a:avLst/>
-          </a:prstGeom>
-        </p:spPr>
-        <p:txBody>
-          <a:bodyPr vert="horz" lIns="91440" tIns="45720" rIns="91440" bIns="45720" rtlCol="0"/>
-          <a:lstStyle>
-            <a:lvl1pPr algn="l">
-              <a:defRPr sz="1200"/>
-            </a:lvl1pPr>
-          </a:lstStyle>
-          <a:p>
-            <a:endParaRPr lang="en-US"/>
-          </a:p>
-        </p:txBody>
-      </p:sp>
-      <p:sp>
-        <p:nvSpPr>
-          <p:cNvPr id="3" name="Date Placeholder 2"/>
-          <p:cNvSpPr>
-            <a:spLocks noGrp="1"/>
-          </p:cNvSpPr>
-          <p:nvPr>
-            <p:ph type="dt" idx="1"/>
-          </p:nvPr>
-        </p:nvSpPr>
-        <p:spPr>
-          <a:xfrm>
-            <a:off x="3884613" y="0"/>
-            <a:ext cx="2971800" cy="458788"/>
-          </a:xfrm>
-          <a:prstGeom prst="rect">
-            <a:avLst/>
-          </a:prstGeom>
-        </p:spPr>
-        <p:txBody>
-          <a:bodyPr vert="horz" lIns="91440" tIns="45720" rIns="91440" bIns="45720" rtlCol="0"/>
-          <a:lstStyle>
-            <a:lvl1pPr algn="r">
-              <a:defRPr sz="1200"/>
-            </a:lvl1pPr>
-          </a:lstStyle>
-          <a:p>
-            <a:fld id="{5282F153-3F37-0F45-9E97-73ACFA13230C}" type="datetimeFigureOut">
-              <a:rPr lang="en-US"/>
-              <a:t>7/23/19</a:t>
-            </a:fld>
-            <a:endParaRPr lang="en-US"/>
-          </a:p>
-        </p:txBody>
-      </p:sp>
-      <p:sp>
-        <p:nvSpPr>
-          <p:cNvPr id="4" name="Slide Image Placeholder 3"/>
-          <p:cNvSpPr>
-            <a:spLocks noGrp="1" noRot="1" noChangeAspect="1"/>
-          </p:cNvSpPr>
-          <p:nvPr>
-            <p:ph type="sldImg" idx="2"/>
-          </p:nvPr>
-        </p:nvSpPr>
-        <p:spPr>
-          <a:xfrm>
-            <a:off x="685800" y="1143000"/>
-            <a:ext cx="5486400" cy="3086100"/>
-          </a:xfrm>
-          <a:prstGeom prst="rect">
-            <a:avLst/>
-          </a:prstGeom>
-          <a:noFill/>
-          <a:ln w="12700">
-            <a:solidFill>
-              <a:prstClr val="black"/>
-            </a:solidFill>
-          </a:ln>
-        </p:spPr>
-        <p:txBody>
-          <a:bodyPr vert="horz" lIns="91440" tIns="45720" rIns="91440" bIns="45720" rtlCol="0" anchor="ctr"/>
-          <a:lstStyle/>
-          <a:p>
-            <a:endParaRPr lang="en-US"/>
-          </a:p>
-        </p:txBody>
-      </p:sp>
-      <p:sp>
-        <p:nvSpPr>
-          <p:cNvPr id="5" name="Notes Placeholder 4"/>
-          <p:cNvSpPr>
-            <a:spLocks noGrp="1"/>
-          </p:cNvSpPr>
-          <p:nvPr>
-            <p:ph type="body" sz="quarter" idx="3"/>
-          </p:nvPr>
-        </p:nvSpPr>
-        <p:spPr>
-          <a:xfrm>
-            <a:off x="685800" y="4400550"/>
-            <a:ext cx="5486400" cy="3600450"/>
-          </a:xfrm>
-          <a:prstGeom prst="rect">
-            <a:avLst/>
-          </a:prstGeom>
-        </p:spPr>
-        <p:txBody>
-          <a:bodyPr vert="horz" lIns="91440" tIns="45720" rIns="91440" bIns="45720" rtlCol="0"/>
-          <a:lstStyle/>
-          <a:p>
-            <a:pPr lvl="0"/>
-            <a:r>
-              <a:rPr lang="en-US"/>
-              <a:t>Click to edit Master text styles</a:t>
-            </a:r>
-          </a:p>
-          <a:p>
-            <a:pPr lvl="1"/>
-            <a:r>
-              <a:rPr lang="en-US"/>
-              <a:t>Second level</a:t>
-            </a:r>
-          </a:p>
-          <a:p>
-            <a:pPr lvl="2"/>
-            <a:r>
-              <a:rPr lang="en-US"/>
-              <a:t>Third level</a:t>
-            </a:r>
-          </a:p>
-          <a:p>
-            <a:pPr lvl="3"/>
-            <a:r>
-              <a:rPr lang="en-US"/>
-              <a:t>Fourth level</a:t>
-            </a:r>
-          </a:p>
-          <a:p>
-            <a:pPr lvl="4"/>
-            <a:r>
-              <a:rPr lang="en-US"/>
-              <a:t>Fifth level</a:t>
-            </a:r>
-          </a:p>
-        </p:txBody>
-      </p:sp>
-      <p:sp>
-        <p:nvSpPr>
-          <p:cNvPr id="6" name="Footer Placeholder 5"/>
-          <p:cNvSpPr>
-            <a:spLocks noGrp="1"/>
-          </p:cNvSpPr>
-          <p:nvPr>
-            <p:ph type="ftr" sz="quarter" idx="4"/>
-          </p:nvPr>
-        </p:nvSpPr>
-        <p:spPr>
-          <a:xfrm>
-            <a:off x="0" y="8685213"/>
-            <a:ext cx="2971800" cy="458787"/>
-          </a:xfrm>
-          <a:prstGeom prst="rect">
-            <a:avLst/>
-          </a:prstGeom>
-        </p:spPr>
-        <p:txBody>
-          <a:bodyPr vert="horz" lIns="91440" tIns="45720" rIns="91440" bIns="45720" rtlCol="0" anchor="b"/>
-          <a:lstStyle>
-            <a:lvl1pPr algn="l">
-              <a:defRPr sz="1200"/>
-            </a:lvl1pPr>
-          </a:lstStyle>
-          <a:p>
-            <a:endParaRPr lang="en-US"/>
-          </a:p>
-        </p:txBody>
-      </p:sp>
-      <p:sp>
-        <p:nvSpPr>
-          <p:cNvPr id="7" name="Slide Number Placeholder 6"/>
-          <p:cNvSpPr>
-            <a:spLocks noGrp="1"/>
-          </p:cNvSpPr>
-          <p:nvPr>
-            <p:ph type="sldNum" sz="quarter" idx="5"/>
-          </p:nvPr>
-        </p:nvSpPr>
-        <p:spPr>
-          <a:xfrm>
-            <a:off x="3884613" y="8685213"/>
-            <a:ext cx="2971800" cy="458787"/>
-          </a:xfrm>
-          <a:prstGeom prst="rect">
-            <a:avLst/>
-          </a:prstGeom>
-        </p:spPr>
-        <p:txBody>
-          <a:bodyPr vert="horz" lIns="91440" tIns="45720" rIns="91440" bIns="45720" rtlCol="0" anchor="b"/>
-          <a:lstStyle>
-            <a:lvl1pPr algn="r">
-              <a:defRPr sz="1200"/>
-            </a:lvl1pPr>
-          </a:lstStyle>
-          <a:p>
-            <a:fld id="{CE5E9CC1-C706-0F49-92D6-E571CC5EEA8F}" type="slidenum">
-              <a:rPr lang="en-US"/>
-              <a:t>‹#›</a:t>
-            </a:fld>
-            <a:endParaRPr lang="en-US"/>
-          </a:p>
-        </p:txBody>
-      </p:sp>
     </p:spTree>
     <p:extLst>
       <p:ext uri="{BB962C8B-B14F-4D97-AF65-F5344CB8AC3E}">
-        <p14:creationId xmlns:p14="http://schemas.microsoft.com/office/powerpoint/2010/main" val="1024086991"/>
+        <p14:creationId xmlns:p14="http://schemas.microsoft.com/office/powerpoint/2010/main" val="1814519253"/>
       </p:ext>
     </p:extLst>
   </p:cSld>
   <p:clrMap bg1="lt1" tx1="dk1" bg2="lt2" tx2="dk2" accent1="accent1" accent2="accent2" accent3="accent3" accent4="accent4" accent5="accent5" accent6="accent6" hlink="hlink" folHlink="folHlink"/>
   <p:notesStyle>
-    <a:lvl1pPr marL="0" algn="l" defTabSz="914400" rtl="0" eaLnBrk="1" latinLnBrk="0" hangingPunct="1">
+    <a:lvl1pPr marL="0" algn="l" defTabSz="914400" rtl="0" eaLnBrk="1" latinLnBrk="1" hangingPunct="1">
       <a:defRPr sz="1200" kern="1200">
         <a:solidFill>
           <a:schemeClr val="tx1"/>
@@ -372,7 +154,7 @@
         <a:cs typeface="+mn-cs"/>
       </a:defRPr>
     </a:lvl1pPr>
-    <a:lvl2pPr marL="457200" algn="l" defTabSz="914400" rtl="0" eaLnBrk="1" latinLnBrk="0" hangingPunct="1">
+    <a:lvl2pPr marL="457200" algn="l" defTabSz="914400" rtl="0" eaLnBrk="1" latinLnBrk="1" hangingPunct="1">
       <a:defRPr sz="1200" kern="1200">
         <a:solidFill>
           <a:schemeClr val="tx1"/>
@@ -382,7 +164,7 @@
         <a:cs typeface="+mn-cs"/>
       </a:defRPr>
     </a:lvl2pPr>
-    <a:lvl3pPr marL="914400" algn="l" defTabSz="914400" rtl="0" eaLnBrk="1" latinLnBrk="0" hangingPunct="1">
+    <a:lvl3pPr marL="914400" algn="l" defTabSz="914400" rtl="0" eaLnBrk="1" latinLnBrk="1" hangingPunct="1">
       <a:defRPr sz="1200" kern="1200">
         <a:solidFill>
           <a:schemeClr val="tx1"/>
@@ -392,7 +174,7 @@
         <a:cs typeface="+mn-cs"/>
       </a:defRPr>
     </a:lvl3pPr>
-    <a:lvl4pPr marL="1371600" algn="l" defTabSz="914400" rtl="0" eaLnBrk="1" latinLnBrk="0" hangingPunct="1">
+    <a:lvl4pPr marL="1371600" algn="l" defTabSz="914400" rtl="0" eaLnBrk="1" latinLnBrk="1" hangingPunct="1">
       <a:defRPr sz="1200" kern="1200">
         <a:solidFill>
           <a:schemeClr val="tx1"/>
@@ -402,7 +184,7 @@
         <a:cs typeface="+mn-cs"/>
       </a:defRPr>
     </a:lvl4pPr>
-    <a:lvl5pPr marL="1828800" algn="l" defTabSz="914400" rtl="0" eaLnBrk="1" latinLnBrk="0" hangingPunct="1">
+    <a:lvl5pPr marL="1828800" algn="l" defTabSz="914400" rtl="0" eaLnBrk="1" latinLnBrk="1" hangingPunct="1">
       <a:defRPr sz="1200" kern="1200">
         <a:solidFill>
           <a:schemeClr val="tx1"/>
@@ -412,7 +194,7 @@
         <a:cs typeface="+mn-cs"/>
       </a:defRPr>
     </a:lvl5pPr>
-    <a:lvl6pPr marL="2286000" algn="l" defTabSz="914400" rtl="0" eaLnBrk="1" latinLnBrk="0" hangingPunct="1">
+    <a:lvl6pPr marL="2286000" algn="l" defTabSz="914400" rtl="0" eaLnBrk="1" latinLnBrk="1" hangingPunct="1">
       <a:defRPr sz="1200" kern="1200">
         <a:solidFill>
           <a:schemeClr val="tx1"/>
@@ -422,7 +204,7 @@
         <a:cs typeface="+mn-cs"/>
       </a:defRPr>
     </a:lvl6pPr>
-    <a:lvl7pPr marL="2743200" algn="l" defTabSz="914400" rtl="0" eaLnBrk="1" latinLnBrk="0" hangingPunct="1">
+    <a:lvl7pPr marL="2743200" algn="l" defTabSz="914400" rtl="0" eaLnBrk="1" latinLnBrk="1" hangingPunct="1">
       <a:defRPr sz="1200" kern="1200">
         <a:solidFill>
           <a:schemeClr val="tx1"/>
@@ -432,7 +214,7 @@
         <a:cs typeface="+mn-cs"/>
       </a:defRPr>
     </a:lvl7pPr>
-    <a:lvl8pPr marL="3200400" algn="l" defTabSz="914400" rtl="0" eaLnBrk="1" latinLnBrk="0" hangingPunct="1">
+    <a:lvl8pPr marL="3200400" algn="l" defTabSz="914400" rtl="0" eaLnBrk="1" latinLnBrk="1" hangingPunct="1">
       <a:defRPr sz="1200" kern="1200">
         <a:solidFill>
           <a:schemeClr val="tx1"/>
@@ -442,7 +224,7 @@
         <a:cs typeface="+mn-cs"/>
       </a:defRPr>
     </a:lvl8pPr>
-    <a:lvl9pPr marL="3657600" algn="l" defTabSz="914400" rtl="0" eaLnBrk="1" latinLnBrk="0" hangingPunct="1">
+    <a:lvl9pPr marL="3657600" algn="l" defTabSz="914400" rtl="0" eaLnBrk="1" latinLnBrk="1" hangingPunct="1">
       <a:defRPr sz="1200" kern="1200">
         <a:solidFill>
           <a:schemeClr val="tx1"/>
@@ -500,10 +282,6 @@
           <a:bodyPr/>
           <a:lstStyle/>
           <a:p>
-            <a:r>
-              <a:rPr lang="en-US" dirty="0"/>
-              <a:t/>
-            </a:r>
             <a:endParaRPr lang="en-US" dirty="0"/>
           </a:p>
         </p:txBody>
@@ -577,6 +355,11 @@
 <file path=ppt/slideMasters/slideMaster1.xml><?xml version="1.0" encoding="utf-8"?>
 <p:sldMaster xmlns:a="http://schemas.openxmlformats.org/drawingml/2006/main" xmlns:r="http://schemas.openxmlformats.org/officeDocument/2006/relationships" xmlns:p="http://schemas.openxmlformats.org/presentationml/2006/main">
   <p:cSld>
+    <p:bg>
+      <p:bgRef idx="1001">
+        <a:schemeClr val="bg1"/>
+      </p:bgRef>
+    </p:bg>
     <p:spTree>
       <p:nvGrpSpPr>
         <p:cNvPr id="1" name=""/>
@@ -859,6 +642,7 @@
         <a:solidFill>
           <a:srgbClr val="FFFFFF"/>
         </a:solidFill>
+        <a:effectLst/>
       </p:bgPr>
     </p:bg>
     <p:spTree>
@@ -883,7 +667,7 @@
         </p:nvSpPr>
         <p:spPr>
           <a:xfrm>
-            <a:off x="365760" y="256032"/>
+            <a:off x="365760" y="201168"/>
             <a:ext cx="11457432" cy="640080"/>
           </a:xfrm>
           <a:prstGeom prst="rect">
@@ -896,19 +680,19 @@
           <a:bodyPr wrap="square" rtlCol="0" anchor="ctr"/>
           <a:lstStyle/>
           <a:p>
-            <a:pPr algn="ctr" indent="0" marL="0">
+            <a:pPr marL="0" indent="0" algn="ctr">
               <a:buNone/>
             </a:pPr>
             <a:r>
               <a:rPr lang="en-US" sz="2400" b="1" dirty="0">
                 <a:solidFill>
-                  <a:srgbClr val="111111"/>
+                  <a:srgbClr val="000000"/>
                 </a:solidFill>
                 <a:latin typeface="Calibri" pitchFamily="34" charset="0"/>
                 <a:ea typeface="Calibri" pitchFamily="34" charset="-122"/>
                 <a:cs typeface="Calibri" pitchFamily="34" charset="-120"/>
               </a:rPr>
-              <a:t>H1 and H2 Tradeoff - Physical AI Actions</a:t>
+              <a:t>Harmless and Helpful Tradeoff - Physical AI Actions</a:t>
             </a:r>
             <a:endParaRPr lang="en-US" sz="2400" dirty="0"/>
           </a:p>
@@ -922,22 +706,31 @@
         </p:nvSpPr>
         <p:spPr>
           <a:xfrm>
-            <a:off x="2331720" y="1325880"/>
-            <a:ext cx="4434840" cy="2057400"/>
+            <a:off x="2148840" y="1234440"/>
+            <a:ext cx="4480560" cy="2103120"/>
           </a:xfrm>
-          <a:prstGeom prst="rect">
-            <a:avLst/>
+          <a:prstGeom prst="roundRect">
+            <a:avLst>
+              <a:gd name="adj" fmla="val 3478"/>
+            </a:avLst>
           </a:prstGeom>
           <a:solidFill>
-            <a:srgbClr val="EDEDED"/>
-          </a:solidFill>
-          <a:ln w="12700">
+            <a:srgbClr val="EFEFEF"/>
+          </a:solidFill>
+          <a:ln w="25400">
             <a:solidFill>
-              <a:srgbClr val="9A9A9A"/>
+              <a:srgbClr val="000000"/>
             </a:solidFill>
             <a:prstDash val="solid"/>
           </a:ln>
         </p:spPr>
+        <p:txBody>
+          <a:bodyPr/>
+          <a:lstStyle/>
+          <a:p>
+            <a:endParaRPr lang="ko-KR" altLang="en-US"/>
+          </a:p>
+        </p:txBody>
       </p:sp>
       <p:sp>
         <p:nvSpPr>
@@ -947,8 +740,8 @@
         </p:nvSpPr>
         <p:spPr>
           <a:xfrm>
-            <a:off x="2331720" y="1325880"/>
-            <a:ext cx="4434840" cy="2057400"/>
+            <a:off x="2148840" y="1234440"/>
+            <a:ext cx="4480560" cy="2103120"/>
           </a:xfrm>
           <a:prstGeom prst="rect">
             <a:avLst/>
@@ -960,16 +753,16 @@
           <a:bodyPr wrap="square" lIns="50800" tIns="50800" rIns="50800" bIns="50800" rtlCol="0" anchor="ctr"/>
           <a:lstStyle/>
           <a:p>
-            <a:pPr algn="ctr" indent="0" marL="0">
+            <a:pPr marL="0" indent="0" algn="ctr">
               <a:lnSpc>
-                <a:spcPct val="112000"/>
+                <a:spcPct val="108000"/>
               </a:lnSpc>
               <a:buNone/>
             </a:pPr>
             <a:r>
               <a:rPr lang="en-US" sz="1700" b="1" dirty="0">
                 <a:solidFill>
-                  <a:srgbClr val="111111"/>
+                  <a:srgbClr val="000000"/>
                 </a:solidFill>
                 <a:latin typeface="Calibri" pitchFamily="34" charset="0"/>
                 <a:ea typeface="Calibri" pitchFamily="34" charset="-122"/>
@@ -980,34 +773,34 @@
             <a:endParaRPr lang="en-US" sz="1700" dirty="0"/>
           </a:p>
           <a:p>
-            <a:pPr algn="ctr" indent="0" marL="0">
+            <a:pPr marL="0" indent="0" algn="ctr">
               <a:lnSpc>
-                <a:spcPct val="112000"/>
+                <a:spcPct val="108000"/>
               </a:lnSpc>
               <a:buNone/>
             </a:pPr>
             <a:r>
               <a:rPr lang="en-US" sz="1250" dirty="0">
                 <a:solidFill>
-                  <a:srgbClr val="7A7A7A"/>
+                  <a:srgbClr val="000000"/>
                 </a:solidFill>
                 <a:latin typeface="Apple SD Gothic Neo" pitchFamily="34" charset="0"/>
                 <a:ea typeface="Apple SD Gothic Neo" pitchFamily="34" charset="-122"/>
                 <a:cs typeface="Apple SD Gothic Neo" pitchFamily="34" charset="-120"/>
               </a:rPr>
-              <a:t>(안전하나 비효율적)</a:t>
+              <a:t>안전하나 비효율적</a:t>
             </a:r>
             <a:endParaRPr lang="en-US" sz="1700" dirty="0"/>
           </a:p>
           <a:p>
-            <a:pPr algn="ctr" indent="0" marL="0">
+            <a:pPr marL="0" indent="0" algn="ctr">
               <a:lnSpc>
-                <a:spcPct val="112000"/>
+                <a:spcPct val="108000"/>
               </a:lnSpc>
               <a:buNone/>
             </a:pPr>
             <a:r>
-              <a:rPr lang="en-US" sz="800" dirty="0">
+              <a:rPr lang="en-US" sz="500" dirty="0">
                 <a:solidFill>
                   <a:srgbClr val="000000"/>
                 </a:solidFill>
@@ -1017,16 +810,16 @@
             <a:endParaRPr lang="en-US" sz="1700" dirty="0"/>
           </a:p>
           <a:p>
-            <a:pPr algn="ctr" indent="0" marL="0">
+            <a:pPr marL="0" indent="0" algn="ctr">
               <a:lnSpc>
-                <a:spcPct val="112000"/>
+                <a:spcPct val="108000"/>
               </a:lnSpc>
               <a:buNone/>
             </a:pPr>
             <a:r>
-              <a:rPr lang="en-US" sz="1100" dirty="0">
-                <a:solidFill>
-                  <a:srgbClr val="7A7A7A"/>
+              <a:rPr lang="en-US" sz="1050" dirty="0">
+                <a:solidFill>
+                  <a:srgbClr val="000000"/>
                 </a:solidFill>
                 <a:latin typeface="Calibri" pitchFamily="34" charset="0"/>
                 <a:ea typeface="Calibri" pitchFamily="34" charset="-122"/>
@@ -1046,22 +839,31 @@
         </p:nvSpPr>
         <p:spPr>
           <a:xfrm>
-            <a:off x="6766560" y="1325880"/>
-            <a:ext cx="4434840" cy="2057400"/>
+            <a:off x="6830568" y="1234440"/>
+            <a:ext cx="4480560" cy="2103120"/>
           </a:xfrm>
-          <a:prstGeom prst="rect">
-            <a:avLst/>
+          <a:prstGeom prst="roundRect">
+            <a:avLst>
+              <a:gd name="adj" fmla="val 3478"/>
+            </a:avLst>
           </a:prstGeom>
           <a:solidFill>
             <a:srgbClr val="FFFFFF"/>
           </a:solidFill>
-          <a:ln w="12700">
+          <a:ln w="25400">
             <a:solidFill>
-              <a:srgbClr val="9A9A9A"/>
+              <a:srgbClr val="000000"/>
             </a:solidFill>
             <a:prstDash val="solid"/>
           </a:ln>
         </p:spPr>
+        <p:txBody>
+          <a:bodyPr/>
+          <a:lstStyle/>
+          <a:p>
+            <a:endParaRPr lang="ko-KR" altLang="en-US"/>
+          </a:p>
+        </p:txBody>
       </p:sp>
       <p:sp>
         <p:nvSpPr>
@@ -1071,8 +873,8 @@
         </p:nvSpPr>
         <p:spPr>
           <a:xfrm>
-            <a:off x="6766560" y="1325880"/>
-            <a:ext cx="4434840" cy="2057400"/>
+            <a:off x="6830568" y="1234440"/>
+            <a:ext cx="4480560" cy="2103120"/>
           </a:xfrm>
           <a:prstGeom prst="rect">
             <a:avLst/>
@@ -1084,54 +886,54 @@
           <a:bodyPr wrap="square" lIns="50800" tIns="50800" rIns="50800" bIns="50800" rtlCol="0" anchor="ctr"/>
           <a:lstStyle/>
           <a:p>
-            <a:pPr algn="ctr" indent="0" marL="0">
+            <a:pPr marL="0" indent="0" algn="ctr">
               <a:lnSpc>
-                <a:spcPct val="112000"/>
+                <a:spcPct val="108000"/>
               </a:lnSpc>
               <a:buNone/>
             </a:pPr>
             <a:r>
               <a:rPr lang="en-US" sz="1700" b="1" dirty="0">
                 <a:solidFill>
-                  <a:srgbClr val="111111"/>
+                  <a:srgbClr val="000000"/>
                 </a:solidFill>
                 <a:latin typeface="Calibri" pitchFamily="34" charset="0"/>
                 <a:ea typeface="Calibri" pitchFamily="34" charset="-122"/>
                 <a:cs typeface="Calibri" pitchFamily="34" charset="-120"/>
               </a:rPr>
-              <a:t>Efficient · Safe</a:t>
+              <a:t>Safe · Efficient</a:t>
             </a:r>
             <a:endParaRPr lang="en-US" sz="1700" dirty="0"/>
           </a:p>
           <a:p>
-            <a:pPr algn="ctr" indent="0" marL="0">
+            <a:pPr marL="0" indent="0" algn="ctr">
               <a:lnSpc>
-                <a:spcPct val="112000"/>
+                <a:spcPct val="108000"/>
               </a:lnSpc>
               <a:buNone/>
             </a:pPr>
             <a:r>
               <a:rPr lang="en-US" sz="1250" dirty="0">
                 <a:solidFill>
-                  <a:srgbClr val="7A7A7A"/>
+                  <a:srgbClr val="000000"/>
                 </a:solidFill>
                 <a:latin typeface="Apple SD Gothic Neo" pitchFamily="34" charset="0"/>
                 <a:ea typeface="Apple SD Gothic Neo" pitchFamily="34" charset="-122"/>
                 <a:cs typeface="Apple SD Gothic Neo" pitchFamily="34" charset="-120"/>
               </a:rPr>
-              <a:t>(효율적이고 안전한)</a:t>
+              <a:t>효율적이고 안전한</a:t>
             </a:r>
             <a:endParaRPr lang="en-US" sz="1700" dirty="0"/>
           </a:p>
           <a:p>
-            <a:pPr algn="ctr" indent="0" marL="0">
+            <a:pPr marL="0" indent="0" algn="ctr">
               <a:lnSpc>
-                <a:spcPct val="112000"/>
+                <a:spcPct val="108000"/>
               </a:lnSpc>
               <a:buNone/>
             </a:pPr>
             <a:r>
-              <a:rPr lang="en-US" sz="800" dirty="0">
+              <a:rPr lang="en-US" sz="500" dirty="0">
                 <a:solidFill>
                   <a:srgbClr val="000000"/>
                 </a:solidFill>
@@ -1141,16 +943,16 @@
             <a:endParaRPr lang="en-US" sz="1700" dirty="0"/>
           </a:p>
           <a:p>
-            <a:pPr algn="ctr" indent="0" marL="0">
+            <a:pPr marL="0" indent="0" algn="ctr">
               <a:lnSpc>
-                <a:spcPct val="112000"/>
+                <a:spcPct val="108000"/>
               </a:lnSpc>
               <a:buNone/>
             </a:pPr>
             <a:r>
-              <a:rPr lang="en-US" sz="1100" dirty="0">
-                <a:solidFill>
-                  <a:srgbClr val="7A7A7A"/>
+              <a:rPr lang="en-US" sz="1050" dirty="0">
+                <a:solidFill>
+                  <a:srgbClr val="000000"/>
                 </a:solidFill>
                 <a:latin typeface="Calibri" pitchFamily="34" charset="0"/>
                 <a:ea typeface="Calibri" pitchFamily="34" charset="-122"/>
@@ -1170,22 +972,31 @@
         </p:nvSpPr>
         <p:spPr>
           <a:xfrm>
-            <a:off x="2331720" y="3383280"/>
-            <a:ext cx="4434840" cy="2057400"/>
+            <a:off x="2148840" y="3538728"/>
+            <a:ext cx="4480560" cy="2103120"/>
           </a:xfrm>
-          <a:prstGeom prst="rect">
-            <a:avLst/>
+          <a:prstGeom prst="roundRect">
+            <a:avLst>
+              <a:gd name="adj" fmla="val 3478"/>
+            </a:avLst>
           </a:prstGeom>
           <a:solidFill>
-            <a:srgbClr val="C4CAD6"/>
-          </a:solidFill>
-          <a:ln w="12700">
+            <a:srgbClr val="A6A6A6"/>
+          </a:solidFill>
+          <a:ln w="25400">
             <a:solidFill>
-              <a:srgbClr val="9A9A9A"/>
+              <a:srgbClr val="000000"/>
             </a:solidFill>
             <a:prstDash val="solid"/>
           </a:ln>
         </p:spPr>
+        <p:txBody>
+          <a:bodyPr/>
+          <a:lstStyle/>
+          <a:p>
+            <a:endParaRPr lang="ko-KR" altLang="en-US"/>
+          </a:p>
+        </p:txBody>
       </p:sp>
       <p:sp>
         <p:nvSpPr>
@@ -1195,8 +1006,8 @@
         </p:nvSpPr>
         <p:spPr>
           <a:xfrm>
-            <a:off x="2331720" y="3383280"/>
-            <a:ext cx="4434840" cy="2057400"/>
+            <a:off x="2148840" y="3538728"/>
+            <a:ext cx="4480560" cy="2103120"/>
           </a:xfrm>
           <a:prstGeom prst="rect">
             <a:avLst/>
@@ -1208,16 +1019,16 @@
           <a:bodyPr wrap="square" lIns="50800" tIns="50800" rIns="50800" bIns="50800" rtlCol="0" anchor="ctr"/>
           <a:lstStyle/>
           <a:p>
-            <a:pPr algn="ctr" indent="0" marL="0">
+            <a:pPr marL="0" indent="0" algn="ctr">
               <a:lnSpc>
-                <a:spcPct val="112000"/>
+                <a:spcPct val="108000"/>
               </a:lnSpc>
               <a:buNone/>
             </a:pPr>
             <a:r>
               <a:rPr lang="en-US" sz="1700" b="1" dirty="0">
                 <a:solidFill>
-                  <a:srgbClr val="111111"/>
+                  <a:srgbClr val="000000"/>
                 </a:solidFill>
                 <a:latin typeface="Calibri" pitchFamily="34" charset="0"/>
                 <a:ea typeface="Calibri" pitchFamily="34" charset="-122"/>
@@ -1228,34 +1039,34 @@
             <a:endParaRPr lang="en-US" sz="1700" dirty="0"/>
           </a:p>
           <a:p>
-            <a:pPr algn="ctr" indent="0" marL="0">
+            <a:pPr marL="0" indent="0" algn="ctr">
               <a:lnSpc>
-                <a:spcPct val="112000"/>
+                <a:spcPct val="108000"/>
               </a:lnSpc>
               <a:buNone/>
             </a:pPr>
             <a:r>
               <a:rPr lang="en-US" sz="1250" dirty="0">
                 <a:solidFill>
-                  <a:srgbClr val="7A7A7A"/>
+                  <a:srgbClr val="000000"/>
                 </a:solidFill>
                 <a:latin typeface="Apple SD Gothic Neo" pitchFamily="34" charset="0"/>
                 <a:ea typeface="Apple SD Gothic Neo" pitchFamily="34" charset="-122"/>
                 <a:cs typeface="Apple SD Gothic Neo" pitchFamily="34" charset="-120"/>
               </a:rPr>
-              <a:t>(위험하고 비효율적)</a:t>
+              <a:t>위험하고 비효율적</a:t>
             </a:r>
             <a:endParaRPr lang="en-US" sz="1700" dirty="0"/>
           </a:p>
           <a:p>
-            <a:pPr algn="ctr" indent="0" marL="0">
+            <a:pPr marL="0" indent="0" algn="ctr">
               <a:lnSpc>
-                <a:spcPct val="112000"/>
+                <a:spcPct val="108000"/>
               </a:lnSpc>
               <a:buNone/>
             </a:pPr>
             <a:r>
-              <a:rPr lang="en-US" sz="800" dirty="0">
+              <a:rPr lang="en-US" sz="500" dirty="0">
                 <a:solidFill>
                   <a:srgbClr val="000000"/>
                 </a:solidFill>
@@ -1265,16 +1076,16 @@
             <a:endParaRPr lang="en-US" sz="1700" dirty="0"/>
           </a:p>
           <a:p>
-            <a:pPr algn="ctr" indent="0" marL="0">
+            <a:pPr marL="0" indent="0" algn="ctr">
               <a:lnSpc>
-                <a:spcPct val="112000"/>
+                <a:spcPct val="108000"/>
               </a:lnSpc>
               <a:buNone/>
             </a:pPr>
             <a:r>
-              <a:rPr lang="en-US" sz="1100" dirty="0">
-                <a:solidFill>
-                  <a:srgbClr val="7A7A7A"/>
+              <a:rPr lang="en-US" sz="1050" dirty="0">
+                <a:solidFill>
+                  <a:srgbClr val="000000"/>
                 </a:solidFill>
                 <a:latin typeface="Calibri" pitchFamily="34" charset="0"/>
                 <a:ea typeface="Calibri" pitchFamily="34" charset="-122"/>
@@ -1294,22 +1105,31 @@
         </p:nvSpPr>
         <p:spPr>
           <a:xfrm>
-            <a:off x="6766560" y="3383280"/>
-            <a:ext cx="4434840" cy="2057400"/>
+            <a:off x="6830568" y="3538728"/>
+            <a:ext cx="4480560" cy="2103120"/>
           </a:xfrm>
-          <a:prstGeom prst="rect">
-            <a:avLst/>
+          <a:prstGeom prst="roundRect">
+            <a:avLst>
+              <a:gd name="adj" fmla="val 3478"/>
+            </a:avLst>
           </a:prstGeom>
           <a:solidFill>
-            <a:srgbClr val="EDEDED"/>
-          </a:solidFill>
-          <a:ln w="12700">
+            <a:srgbClr val="CFCFCF"/>
+          </a:solidFill>
+          <a:ln w="25400">
             <a:solidFill>
-              <a:srgbClr val="9A9A9A"/>
+              <a:srgbClr val="000000"/>
             </a:solidFill>
             <a:prstDash val="solid"/>
           </a:ln>
         </p:spPr>
+        <p:txBody>
+          <a:bodyPr/>
+          <a:lstStyle/>
+          <a:p>
+            <a:endParaRPr lang="ko-KR" altLang="en-US"/>
+          </a:p>
+        </p:txBody>
       </p:sp>
       <p:sp>
         <p:nvSpPr>
@@ -1319,8 +1139,8 @@
         </p:nvSpPr>
         <p:spPr>
           <a:xfrm>
-            <a:off x="6766560" y="3383280"/>
-            <a:ext cx="4434840" cy="2057400"/>
+            <a:off x="6830568" y="3538728"/>
+            <a:ext cx="4480560" cy="2103120"/>
           </a:xfrm>
           <a:prstGeom prst="rect">
             <a:avLst/>
@@ -1332,54 +1152,54 @@
           <a:bodyPr wrap="square" lIns="50800" tIns="50800" rIns="50800" bIns="50800" rtlCol="0" anchor="ctr"/>
           <a:lstStyle/>
           <a:p>
-            <a:pPr algn="ctr" indent="0" marL="0">
+            <a:pPr marL="0" indent="0" algn="ctr">
               <a:lnSpc>
-                <a:spcPct val="112000"/>
+                <a:spcPct val="108000"/>
               </a:lnSpc>
               <a:buNone/>
             </a:pPr>
             <a:r>
               <a:rPr lang="en-US" sz="1700" b="1" dirty="0">
                 <a:solidFill>
-                  <a:srgbClr val="111111"/>
+                  <a:srgbClr val="000000"/>
                 </a:solidFill>
                 <a:latin typeface="Calibri" pitchFamily="34" charset="0"/>
                 <a:ea typeface="Calibri" pitchFamily="34" charset="-122"/>
                 <a:cs typeface="Calibri" pitchFamily="34" charset="-120"/>
               </a:rPr>
-              <a:t>Efficient · Unsafe</a:t>
+              <a:t>Unsafe · Efficient</a:t>
             </a:r>
             <a:endParaRPr lang="en-US" sz="1700" dirty="0"/>
           </a:p>
           <a:p>
-            <a:pPr algn="ctr" indent="0" marL="0">
+            <a:pPr marL="0" indent="0" algn="ctr">
               <a:lnSpc>
-                <a:spcPct val="112000"/>
+                <a:spcPct val="108000"/>
               </a:lnSpc>
               <a:buNone/>
             </a:pPr>
             <a:r>
               <a:rPr lang="en-US" sz="1250" dirty="0">
                 <a:solidFill>
-                  <a:srgbClr val="7A7A7A"/>
+                  <a:srgbClr val="000000"/>
                 </a:solidFill>
                 <a:latin typeface="Apple SD Gothic Neo" pitchFamily="34" charset="0"/>
                 <a:ea typeface="Apple SD Gothic Neo" pitchFamily="34" charset="-122"/>
                 <a:cs typeface="Apple SD Gothic Neo" pitchFamily="34" charset="-120"/>
               </a:rPr>
-              <a:t>(효율적이나 위험한)</a:t>
+              <a:t>효율적이나 위험한</a:t>
             </a:r>
             <a:endParaRPr lang="en-US" sz="1700" dirty="0"/>
           </a:p>
           <a:p>
-            <a:pPr algn="ctr" indent="0" marL="0">
+            <a:pPr marL="0" indent="0" algn="ctr">
               <a:lnSpc>
-                <a:spcPct val="112000"/>
+                <a:spcPct val="108000"/>
               </a:lnSpc>
               <a:buNone/>
             </a:pPr>
             <a:r>
-              <a:rPr lang="en-US" sz="800" dirty="0">
+              <a:rPr lang="en-US" sz="500" dirty="0">
                 <a:solidFill>
                   <a:srgbClr val="000000"/>
                 </a:solidFill>
@@ -1389,22 +1209,42 @@
             <a:endParaRPr lang="en-US" sz="1700" dirty="0"/>
           </a:p>
           <a:p>
-            <a:pPr algn="ctr" indent="0" marL="0">
+            <a:pPr marL="0" indent="0" algn="ctr">
               <a:lnSpc>
-                <a:spcPct val="112000"/>
+                <a:spcPct val="108000"/>
               </a:lnSpc>
               <a:buNone/>
             </a:pPr>
             <a:r>
-              <a:rPr lang="en-US" sz="1100" dirty="0">
-                <a:solidFill>
-                  <a:srgbClr val="7A7A7A"/>
+              <a:rPr lang="en-US" sz="1050" dirty="0">
+                <a:solidFill>
+                  <a:srgbClr val="000000"/>
                 </a:solidFill>
                 <a:latin typeface="Calibri" pitchFamily="34" charset="0"/>
                 <a:ea typeface="Calibri" pitchFamily="34" charset="-122"/>
                 <a:cs typeface="Calibri" pitchFamily="34" charset="-120"/>
               </a:rPr>
               <a:t>Highest physical-harm risk</a:t>
+            </a:r>
+            <a:endParaRPr lang="en-US" sz="1700" dirty="0"/>
+          </a:p>
+          <a:p>
+            <a:pPr marL="0" indent="0" algn="ctr">
+              <a:lnSpc>
+                <a:spcPct val="108000"/>
+              </a:lnSpc>
+              <a:buNone/>
+            </a:pPr>
+            <a:r>
+              <a:rPr lang="en-US" sz="1050" dirty="0">
+                <a:solidFill>
+                  <a:srgbClr val="000000"/>
+                </a:solidFill>
+                <a:latin typeface="Calibri" pitchFamily="34" charset="0"/>
+                <a:ea typeface="Calibri" pitchFamily="34" charset="-122"/>
+                <a:cs typeface="Calibri" pitchFamily="34" charset="-120"/>
+              </a:rPr>
+              <a:t>(danger from capability, not incompetence)</a:t>
             </a:r>
             <a:endParaRPr lang="en-US" sz="1700" dirty="0"/>
           </a:p>
@@ -1418,8 +1258,8 @@
         </p:nvSpPr>
         <p:spPr>
           <a:xfrm>
-            <a:off x="1234440" y="1325880"/>
-            <a:ext cx="960120" cy="2057400"/>
+            <a:off x="1051560" y="1234440"/>
+            <a:ext cx="960120" cy="2103120"/>
           </a:xfrm>
           <a:prstGeom prst="rect">
             <a:avLst/>
@@ -1431,13 +1271,13 @@
           <a:bodyPr wrap="square" rtlCol="0" anchor="ctr"/>
           <a:lstStyle/>
           <a:p>
-            <a:pPr algn="r" indent="0" marL="0">
+            <a:pPr marL="0" indent="0" algn="r">
               <a:buNone/>
             </a:pPr>
             <a:r>
               <a:rPr lang="en-US" sz="1400" b="1" dirty="0">
                 <a:solidFill>
-                  <a:srgbClr val="111111"/>
+                  <a:srgbClr val="000000"/>
                 </a:solidFill>
                 <a:latin typeface="Calibri" pitchFamily="34" charset="0"/>
                 <a:ea typeface="Calibri" pitchFamily="34" charset="-122"/>
@@ -1457,8 +1297,8 @@
         </p:nvSpPr>
         <p:spPr>
           <a:xfrm>
-            <a:off x="1143000" y="3383280"/>
-            <a:ext cx="1051560" cy="2057400"/>
+            <a:off x="960120" y="3538728"/>
+            <a:ext cx="1051560" cy="2103120"/>
           </a:xfrm>
           <a:prstGeom prst="rect">
             <a:avLst/>
@@ -1470,13 +1310,13 @@
           <a:bodyPr wrap="square" rtlCol="0" anchor="ctr"/>
           <a:lstStyle/>
           <a:p>
-            <a:pPr algn="r" indent="0" marL="0">
+            <a:pPr marL="0" indent="0" algn="r">
               <a:buNone/>
             </a:pPr>
             <a:r>
               <a:rPr lang="en-US" sz="1400" b="1" dirty="0">
                 <a:solidFill>
-                  <a:srgbClr val="111111"/>
+                  <a:srgbClr val="000000"/>
                 </a:solidFill>
                 <a:latin typeface="Calibri" pitchFamily="34" charset="0"/>
                 <a:ea typeface="Calibri" pitchFamily="34" charset="-122"/>
@@ -1496,7 +1336,7 @@
         </p:nvSpPr>
         <p:spPr>
           <a:xfrm rot="16200000">
-            <a:off x="-1234440" y="3154680"/>
+            <a:off x="-1234440" y="3063240"/>
             <a:ext cx="3931920" cy="457200"/>
           </a:xfrm>
           <a:prstGeom prst="rect">
@@ -1509,19 +1349,19 @@
           <a:bodyPr wrap="square" rtlCol="0" anchor="ctr"/>
           <a:lstStyle/>
           <a:p>
-            <a:pPr algn="ctr" indent="0" marL="0">
+            <a:pPr marL="0" indent="0" algn="ctr">
               <a:buNone/>
             </a:pPr>
             <a:r>
               <a:rPr lang="en-US" sz="1500" b="1" dirty="0">
                 <a:solidFill>
-                  <a:srgbClr val="111111"/>
+                  <a:srgbClr val="000000"/>
                 </a:solidFill>
                 <a:latin typeface="Calibri" pitchFamily="34" charset="0"/>
                 <a:ea typeface="Calibri" pitchFamily="34" charset="-122"/>
                 <a:cs typeface="Calibri" pitchFamily="34" charset="-120"/>
               </a:rPr>
-              <a:t>H1: Safety</a:t>
+              <a:t>Safety (Harmlessness)</a:t>
             </a:r>
             <a:endParaRPr lang="en-US" sz="1500" dirty="0"/>
           </a:p>
@@ -1535,8 +1375,8 @@
         </p:nvSpPr>
         <p:spPr>
           <a:xfrm>
-            <a:off x="2331720" y="5513832"/>
-            <a:ext cx="4434840" cy="365760"/>
+            <a:off x="2148840" y="5696712"/>
+            <a:ext cx="4480560" cy="365760"/>
           </a:xfrm>
           <a:prstGeom prst="rect">
             <a:avLst/>
@@ -1548,13 +1388,13 @@
           <a:bodyPr wrap="square" rtlCol="0" anchor="ctr"/>
           <a:lstStyle/>
           <a:p>
-            <a:pPr algn="ctr" indent="0" marL="0">
+            <a:pPr marL="0" indent="0" algn="ctr">
               <a:buNone/>
             </a:pPr>
             <a:r>
               <a:rPr lang="en-US" sz="1400" b="1" dirty="0">
                 <a:solidFill>
-                  <a:srgbClr val="111111"/>
+                  <a:srgbClr val="000000"/>
                 </a:solidFill>
                 <a:latin typeface="Calibri" pitchFamily="34" charset="0"/>
                 <a:ea typeface="Calibri" pitchFamily="34" charset="-122"/>
@@ -1574,8 +1414,8 @@
         </p:nvSpPr>
         <p:spPr>
           <a:xfrm>
-            <a:off x="6766560" y="5513832"/>
-            <a:ext cx="4434840" cy="365760"/>
+            <a:off x="6830568" y="5696712"/>
+            <a:ext cx="4480560" cy="365760"/>
           </a:xfrm>
           <a:prstGeom prst="rect">
             <a:avLst/>
@@ -1587,13 +1427,13 @@
           <a:bodyPr wrap="square" rtlCol="0" anchor="ctr"/>
           <a:lstStyle/>
           <a:p>
-            <a:pPr algn="ctr" indent="0" marL="0">
+            <a:pPr marL="0" indent="0" algn="ctr">
               <a:buNone/>
             </a:pPr>
             <a:r>
               <a:rPr lang="en-US" sz="1400" b="1" dirty="0">
                 <a:solidFill>
-                  <a:srgbClr val="111111"/>
+                  <a:srgbClr val="000000"/>
                 </a:solidFill>
                 <a:latin typeface="Calibri" pitchFamily="34" charset="0"/>
                 <a:ea typeface="Calibri" pitchFamily="34" charset="-122"/>
@@ -1613,8 +1453,8 @@
         </p:nvSpPr>
         <p:spPr>
           <a:xfrm>
-            <a:off x="2331720" y="5971032"/>
-            <a:ext cx="8869680" cy="365760"/>
+            <a:off x="2148840" y="6080760"/>
+            <a:ext cx="9162288" cy="365760"/>
           </a:xfrm>
           <a:prstGeom prst="rect">
             <a:avLst/>
@@ -1626,25 +1466,124 @@
           <a:bodyPr wrap="square" rtlCol="0" anchor="ctr"/>
           <a:lstStyle/>
           <a:p>
-            <a:pPr algn="ctr" indent="0" marL="0">
+            <a:pPr marL="0" indent="0" algn="ctr">
               <a:buNone/>
             </a:pPr>
             <a:r>
               <a:rPr lang="en-US" sz="1500" b="1" dirty="0">
                 <a:solidFill>
-                  <a:srgbClr val="111111"/>
+                  <a:srgbClr val="000000"/>
                 </a:solidFill>
                 <a:latin typeface="Calibri" pitchFamily="34" charset="0"/>
                 <a:ea typeface="Calibri" pitchFamily="34" charset="-122"/>
                 <a:cs typeface="Calibri" pitchFamily="34" charset="-120"/>
               </a:rPr>
-              <a:t>H2: Task Efficiency  ( ↓ time, ↓ energy )</a:t>
+              <a:t>Task Efficiency  ( ↓ time, ↓ energy )</a:t>
             </a:r>
             <a:endParaRPr lang="en-US" sz="1500" dirty="0"/>
+          </a:p>
+        </p:txBody>
+      </p:sp>
+      <p:sp>
+        <p:nvSpPr>
+          <p:cNvPr id="17" name="Text 15"/>
+          <p:cNvSpPr/>
+          <p:nvPr/>
+        </p:nvSpPr>
+        <p:spPr>
+          <a:xfrm>
+            <a:off x="1691640" y="6473952"/>
+            <a:ext cx="10076688" cy="320040"/>
+          </a:xfrm>
+          <a:prstGeom prst="rect">
+            <a:avLst/>
+          </a:prstGeom>
+          <a:noFill/>
+          <a:ln/>
+        </p:spPr>
+        <p:txBody>
+          <a:bodyPr wrap="square" rtlCol="0" anchor="ctr"/>
+          <a:lstStyle/>
+          <a:p>
+            <a:pPr marL="0" indent="0" algn="ctr">
+              <a:buNone/>
+            </a:pPr>
+            <a:r>
+              <a:rPr lang="en-US" sz="1000" i="1" dirty="0">
+                <a:solidFill>
+                  <a:srgbClr val="000000"/>
+                </a:solidFill>
+                <a:latin typeface="Calibri" pitchFamily="34" charset="0"/>
+                <a:ea typeface="Calibri" pitchFamily="34" charset="-122"/>
+                <a:cs typeface="Calibri" pitchFamily="34" charset="-120"/>
+              </a:rPr>
+              <a:t>Efficiency is defined given task completion (else minimizing time/energy degenerates to inaction).</a:t>
+            </a:r>
+            <a:endParaRPr lang="en-US" sz="1000" dirty="0"/>
           </a:p>
         </p:txBody>
       </p:sp>
     </p:spTree>
+  </p:cSld>
+  <p:clrMapOvr>
+    <a:masterClrMapping/>
+  </p:clrMapOvr>
+</p:sld>
+</file>
+
+<file path=ppt/slides/slide2.xml><?xml version="1.0" encoding="utf-8"?>
+<p:sld xmlns:a="http://schemas.openxmlformats.org/drawingml/2006/main" xmlns:r="http://schemas.openxmlformats.org/officeDocument/2006/relationships" xmlns:p="http://schemas.openxmlformats.org/presentationml/2006/main">
+  <p:cSld>
+    <p:spTree>
+      <p:nvGrpSpPr>
+        <p:cNvPr id="1" name=""/>
+        <p:cNvGrpSpPr/>
+        <p:nvPr/>
+      </p:nvGrpSpPr>
+      <p:grpSpPr>
+        <a:xfrm>
+          <a:off x="0" y="0"/>
+          <a:ext cx="0" cy="0"/>
+          <a:chOff x="0" y="0"/>
+          <a:chExt cx="0" cy="0"/>
+        </a:xfrm>
+      </p:grpSpPr>
+      <p:pic>
+        <p:nvPicPr>
+          <p:cNvPr id="2" name="그림 1">
+            <a:extLst>
+              <a:ext uri="{FF2B5EF4-FFF2-40B4-BE49-F238E27FC236}">
+                <a16:creationId xmlns:a16="http://schemas.microsoft.com/office/drawing/2014/main" id="{0E2FBE7E-2E7D-A559-1C22-759952FB9EA5}"/>
+              </a:ext>
+            </a:extLst>
+          </p:cNvPr>
+          <p:cNvPicPr>
+            <a:picLocks noChangeAspect="1"/>
+          </p:cNvPicPr>
+          <p:nvPr/>
+        </p:nvPicPr>
+        <p:blipFill>
+          <a:blip r:embed="rId2"/>
+          <a:stretch>
+            <a:fillRect/>
+          </a:stretch>
+        </p:blipFill>
+        <p:spPr>
+          <a:xfrm>
+            <a:off x="2208212" y="1656184"/>
+            <a:ext cx="7772400" cy="3545632"/>
+          </a:xfrm>
+          <a:prstGeom prst="rect">
+            <a:avLst/>
+          </a:prstGeom>
+        </p:spPr>
+      </p:pic>
+    </p:spTree>
+    <p:extLst>
+      <p:ext uri="{BB962C8B-B14F-4D97-AF65-F5344CB8AC3E}">
+        <p14:creationId xmlns:p14="http://schemas.microsoft.com/office/powerpoint/2010/main" val="2303909093"/>
+      </p:ext>
+    </p:extLst>
   </p:cSld>
   <p:clrMapOvr>
     <a:masterClrMapping/>
@@ -1945,4 +1884,319 @@
     </a:ext>
   </a:extLst>
 </a:theme>
+</file>
+
+<file path=ppt/theme/theme2.xml><?xml version="1.0" encoding="utf-8"?>
+<a:theme xmlns:a="http://schemas.openxmlformats.org/drawingml/2006/main" name="Office 테마">
+  <a:themeElements>
+    <a:clrScheme name="Office">
+      <a:dk1>
+        <a:sysClr val="windowText" lastClr="000000"/>
+      </a:dk1>
+      <a:lt1>
+        <a:sysClr val="window" lastClr="FFFFFF"/>
+      </a:lt1>
+      <a:dk2>
+        <a:srgbClr val="0E2841"/>
+      </a:dk2>
+      <a:lt2>
+        <a:srgbClr val="E8E8E8"/>
+      </a:lt2>
+      <a:accent1>
+        <a:srgbClr val="156082"/>
+      </a:accent1>
+      <a:accent2>
+        <a:srgbClr val="E97132"/>
+      </a:accent2>
+      <a:accent3>
+        <a:srgbClr val="196B24"/>
+      </a:accent3>
+      <a:accent4>
+        <a:srgbClr val="0F9ED5"/>
+      </a:accent4>
+      <a:accent5>
+        <a:srgbClr val="A02B93"/>
+      </a:accent5>
+      <a:accent6>
+        <a:srgbClr val="4EA72E"/>
+      </a:accent6>
+      <a:hlink>
+        <a:srgbClr val="467886"/>
+      </a:hlink>
+      <a:folHlink>
+        <a:srgbClr val="96607D"/>
+      </a:folHlink>
+    </a:clrScheme>
+    <a:fontScheme name="Office">
+      <a:majorFont>
+        <a:latin typeface="맑은 고딕" panose="02110004020202020204"/>
+        <a:ea typeface=""/>
+        <a:cs typeface=""/>
+        <a:font script="Jpan" typeface="游ゴシック Light"/>
+        <a:font script="Hang" typeface="맑은 고딕"/>
+        <a:font script="Hans" typeface="等线 Light"/>
+        <a:font script="Hant" typeface="新細明體"/>
+        <a:font script="Arab" typeface="Times New Roman"/>
+        <a:font script="Hebr" typeface="Times New Roman"/>
+        <a:font script="Thai" typeface="Angsana New"/>
+        <a:font script="Ethi" typeface="Nyala"/>
+        <a:font script="Beng" typeface="Vrinda"/>
+        <a:font script="Gujr" typeface="Shruti"/>
+        <a:font script="Khmr" typeface="MoolBoran"/>
+        <a:font script="Knda" typeface="Tunga"/>
+        <a:font script="Guru" typeface="Raavi"/>
+        <a:font script="Cans" typeface="Euphemia"/>
+        <a:font script="Cher" typeface="Plantagenet Cherokee"/>
+        <a:font script="Yiii" typeface="Microsoft Yi Baiti"/>
+        <a:font script="Tibt" typeface="Microsoft Himalaya"/>
+        <a:font script="Thaa" typeface="MV Boli"/>
+        <a:font script="Deva" typeface="Mangal"/>
+        <a:font script="Telu" typeface="Gautami"/>
+        <a:font script="Taml" typeface="Latha"/>
+        <a:font script="Syrc" typeface="Estrangelo Edessa"/>
+        <a:font script="Orya" typeface="Kalinga"/>
+        <a:font script="Mlym" typeface="Kartika"/>
+        <a:font script="Laoo" typeface="DokChampa"/>
+        <a:font script="Sinh" typeface="Iskoola Pota"/>
+        <a:font script="Mong" typeface="Mongolian Baiti"/>
+        <a:font script="Viet" typeface="Times New Roman"/>
+        <a:font script="Uigh" typeface="Microsoft Uighur"/>
+        <a:font script="Geor" typeface="Sylfaen"/>
+        <a:font script="Armn" typeface="Arial"/>
+        <a:font script="Bugi" typeface="Leelawadee UI"/>
+        <a:font script="Bopo" typeface="Microsoft JhengHei"/>
+        <a:font script="Java" typeface="Javanese Text"/>
+        <a:font script="Lisu" typeface="Segoe UI"/>
+        <a:font script="Mymr" typeface="Myanmar Text"/>
+        <a:font script="Nkoo" typeface="Ebrima"/>
+        <a:font script="Olck" typeface="Nirmala UI"/>
+        <a:font script="Osma" typeface="Ebrima"/>
+        <a:font script="Phag" typeface="Phagspa"/>
+        <a:font script="Syrn" typeface="Estrangelo Edessa"/>
+        <a:font script="Syrj" typeface="Estrangelo Edessa"/>
+        <a:font script="Syre" typeface="Estrangelo Edessa"/>
+        <a:font script="Sora" typeface="Nirmala UI"/>
+        <a:font script="Tale" typeface="Microsoft Tai Le"/>
+        <a:font script="Talu" typeface="Microsoft New Tai Lue"/>
+        <a:font script="Tfng" typeface="Ebrima"/>
+      </a:majorFont>
+      <a:minorFont>
+        <a:latin typeface="맑은 고딕" panose="02110004020202020204"/>
+        <a:ea typeface=""/>
+        <a:cs typeface=""/>
+        <a:font script="Jpan" typeface="游ゴシック"/>
+        <a:font script="Hang" typeface="맑은 고딕"/>
+        <a:font script="Hans" typeface="等线"/>
+        <a:font script="Hant" typeface="新細明體"/>
+        <a:font script="Arab" typeface="Arial"/>
+        <a:font script="Hebr" typeface="Arial"/>
+        <a:font script="Thai" typeface="Cordia New"/>
+        <a:font script="Ethi" typeface="Nyala"/>
+        <a:font script="Beng" typeface="Vrinda"/>
+        <a:font script="Gujr" typeface="Shruti"/>
+        <a:font script="Khmr" typeface="DaunPenh"/>
+        <a:font script="Knda" typeface="Tunga"/>
+        <a:font script="Guru" typeface="Raavi"/>
+        <a:font script="Cans" typeface="Euphemia"/>
+        <a:font script="Cher" typeface="Plantagenet Cherokee"/>
+        <a:font script="Yiii" typeface="Microsoft Yi Baiti"/>
+        <a:font script="Tibt" typeface="Microsoft Himalaya"/>
+        <a:font script="Thaa" typeface="MV Boli"/>
+        <a:font script="Deva" typeface="Mangal"/>
+        <a:font script="Telu" typeface="Gautami"/>
+        <a:font script="Taml" typeface="Latha"/>
+        <a:font script="Syrc" typeface="Estrangelo Edessa"/>
+        <a:font script="Orya" typeface="Kalinga"/>
+        <a:font script="Mlym" typeface="Kartika"/>
+        <a:font script="Laoo" typeface="DokChampa"/>
+        <a:font script="Sinh" typeface="Iskoola Pota"/>
+        <a:font script="Mong" typeface="Mongolian Baiti"/>
+        <a:font script="Viet" typeface="Arial"/>
+        <a:font script="Uigh" typeface="Microsoft Uighur"/>
+        <a:font script="Geor" typeface="Sylfaen"/>
+        <a:font script="Armn" typeface="Arial"/>
+        <a:font script="Bugi" typeface="Leelawadee UI"/>
+        <a:font script="Bopo" typeface="Microsoft JhengHei"/>
+        <a:font script="Java" typeface="Javanese Text"/>
+        <a:font script="Lisu" typeface="Segoe UI"/>
+        <a:font script="Mymr" typeface="Myanmar Text"/>
+        <a:font script="Nkoo" typeface="Ebrima"/>
+        <a:font script="Olck" typeface="Nirmala UI"/>
+        <a:font script="Osma" typeface="Ebrima"/>
+        <a:font script="Phag" typeface="Phagspa"/>
+        <a:font script="Syrn" typeface="Estrangelo Edessa"/>
+        <a:font script="Syrj" typeface="Estrangelo Edessa"/>
+        <a:font script="Syre" typeface="Estrangelo Edessa"/>
+        <a:font script="Sora" typeface="Nirmala UI"/>
+        <a:font script="Tale" typeface="Microsoft Tai Le"/>
+        <a:font script="Talu" typeface="Microsoft New Tai Lue"/>
+        <a:font script="Tfng" typeface="Ebrima"/>
+      </a:minorFont>
+    </a:fontScheme>
+    <a:fmtScheme name="Office">
+      <a:fillStyleLst>
+        <a:solidFill>
+          <a:schemeClr val="phClr"/>
+        </a:solidFill>
+        <a:gradFill rotWithShape="1">
+          <a:gsLst>
+            <a:gs pos="0">
+              <a:schemeClr val="phClr">
+                <a:lumMod val="110000"/>
+                <a:satMod val="105000"/>
+                <a:tint val="67000"/>
+              </a:schemeClr>
+            </a:gs>
+            <a:gs pos="50000">
+              <a:schemeClr val="phClr">
+                <a:lumMod val="105000"/>
+                <a:satMod val="103000"/>
+                <a:tint val="73000"/>
+              </a:schemeClr>
+            </a:gs>
+            <a:gs pos="100000">
+              <a:schemeClr val="phClr">
+                <a:lumMod val="105000"/>
+                <a:satMod val="109000"/>
+                <a:tint val="81000"/>
+              </a:schemeClr>
+            </a:gs>
+          </a:gsLst>
+          <a:lin ang="5400000" scaled="0"/>
+        </a:gradFill>
+        <a:gradFill rotWithShape="1">
+          <a:gsLst>
+            <a:gs pos="0">
+              <a:schemeClr val="phClr">
+                <a:satMod val="103000"/>
+                <a:lumMod val="102000"/>
+                <a:tint val="94000"/>
+              </a:schemeClr>
+            </a:gs>
+            <a:gs pos="50000">
+              <a:schemeClr val="phClr">
+                <a:satMod val="110000"/>
+                <a:lumMod val="100000"/>
+                <a:shade val="100000"/>
+              </a:schemeClr>
+            </a:gs>
+            <a:gs pos="100000">
+              <a:schemeClr val="phClr">
+                <a:lumMod val="99000"/>
+                <a:satMod val="120000"/>
+                <a:shade val="78000"/>
+              </a:schemeClr>
+            </a:gs>
+          </a:gsLst>
+          <a:lin ang="5400000" scaled="0"/>
+        </a:gradFill>
+      </a:fillStyleLst>
+      <a:lnStyleLst>
+        <a:ln w="12700" cap="flat" cmpd="sng" algn="ctr">
+          <a:solidFill>
+            <a:schemeClr val="phClr"/>
+          </a:solidFill>
+          <a:prstDash val="solid"/>
+          <a:miter lim="800000"/>
+        </a:ln>
+        <a:ln w="19050" cap="flat" cmpd="sng" algn="ctr">
+          <a:solidFill>
+            <a:schemeClr val="phClr"/>
+          </a:solidFill>
+          <a:prstDash val="solid"/>
+          <a:miter lim="800000"/>
+        </a:ln>
+        <a:ln w="25400" cap="flat" cmpd="sng" algn="ctr">
+          <a:solidFill>
+            <a:schemeClr val="phClr"/>
+          </a:solidFill>
+          <a:prstDash val="solid"/>
+          <a:miter lim="800000"/>
+        </a:ln>
+      </a:lnStyleLst>
+      <a:effectStyleLst>
+        <a:effectStyle>
+          <a:effectLst/>
+        </a:effectStyle>
+        <a:effectStyle>
+          <a:effectLst/>
+        </a:effectStyle>
+        <a:effectStyle>
+          <a:effectLst>
+            <a:outerShdw blurRad="57150" dist="19050" dir="5400000" algn="ctr" rotWithShape="0">
+              <a:srgbClr val="000000">
+                <a:alpha val="63000"/>
+              </a:srgbClr>
+            </a:outerShdw>
+          </a:effectLst>
+        </a:effectStyle>
+      </a:effectStyleLst>
+      <a:bgFillStyleLst>
+        <a:solidFill>
+          <a:schemeClr val="phClr"/>
+        </a:solidFill>
+        <a:solidFill>
+          <a:schemeClr val="phClr">
+            <a:tint val="95000"/>
+            <a:satMod val="170000"/>
+          </a:schemeClr>
+        </a:solidFill>
+        <a:gradFill rotWithShape="1">
+          <a:gsLst>
+            <a:gs pos="0">
+              <a:schemeClr val="phClr">
+                <a:tint val="93000"/>
+                <a:satMod val="150000"/>
+                <a:shade val="98000"/>
+                <a:lumMod val="102000"/>
+              </a:schemeClr>
+            </a:gs>
+            <a:gs pos="50000">
+              <a:schemeClr val="phClr">
+                <a:tint val="98000"/>
+                <a:satMod val="130000"/>
+                <a:shade val="90000"/>
+                <a:lumMod val="103000"/>
+              </a:schemeClr>
+            </a:gs>
+            <a:gs pos="100000">
+              <a:schemeClr val="phClr">
+                <a:shade val="63000"/>
+                <a:satMod val="120000"/>
+              </a:schemeClr>
+            </a:gs>
+          </a:gsLst>
+          <a:lin ang="5400000" scaled="0"/>
+        </a:gradFill>
+      </a:bgFillStyleLst>
+    </a:fmtScheme>
+  </a:themeElements>
+  <a:objectDefaults>
+    <a:lnDef>
+      <a:spPr/>
+      <a:bodyPr/>
+      <a:lstStyle/>
+      <a:style>
+        <a:lnRef idx="2">
+          <a:schemeClr val="accent1"/>
+        </a:lnRef>
+        <a:fillRef idx="0">
+          <a:schemeClr val="accent1"/>
+        </a:fillRef>
+        <a:effectRef idx="1">
+          <a:schemeClr val="accent1"/>
+        </a:effectRef>
+        <a:fontRef idx="minor">
+          <a:schemeClr val="tx1"/>
+        </a:fontRef>
+      </a:style>
+    </a:lnDef>
+  </a:objectDefaults>
+  <a:extraClrSchemeLst/>
+  <a:extLst>
+    <a:ext uri="{05A4C25C-085E-4340-85A3-A5531E510DB2}">
+      <thm15:themeFamily xmlns:thm15="http://schemas.microsoft.com/office/thememl/2012/main" name="Office Theme" id="{2E142A2C-CD16-42D6-873A-C26D2A0506FA}" vid="{1BDDFF52-6CD6-40A5-AB3C-68EB2F1E4D0A}"/>
+    </a:ext>
+  </a:extLst>
+</a:theme>
 </file>
</xml_diff>